<commit_message>
Added images to mockup
</commit_message>
<xml_diff>
--- a/mockup.pptx
+++ b/mockup.pptx
@@ -2,18 +2,20 @@
 <file path=ppt/presentation.xml><?xml version="1.0" encoding="utf-8"?>
 <p:presentation xmlns:a="http://schemas.openxmlformats.org/drawingml/2006/main" xmlns:r="http://schemas.openxmlformats.org/officeDocument/2006/relationships" xmlns:p="http://schemas.openxmlformats.org/presentationml/2006/main" saveSubsetFonts="1">
   <p:sldMasterIdLst>
-    <p:sldMasterId id="2147483648" r:id="rId1"/>
+    <p:sldMasterId id="2147483660" r:id="rId1"/>
   </p:sldMasterIdLst>
   <p:sldIdLst>
     <p:sldId id="256" r:id="rId2"/>
+    <p:sldId id="257" r:id="rId3"/>
+    <p:sldId id="258" r:id="rId4"/>
   </p:sldIdLst>
-  <p:sldSz cx="12192000" cy="6858000"/>
+  <p:sldSz cx="9144000" cy="6858000" type="screen4x3"/>
   <p:notesSz cx="6858000" cy="9144000"/>
   <p:defaultTextStyle>
     <a:defPPr>
       <a:defRPr lang="en-US"/>
     </a:defPPr>
-    <a:lvl1pPr marL="0" algn="l" defTabSz="914400" rtl="0" eaLnBrk="1" latinLnBrk="0" hangingPunct="1">
+    <a:lvl1pPr marL="0" algn="l" defTabSz="457200" rtl="0" eaLnBrk="1" latinLnBrk="0" hangingPunct="1">
       <a:defRPr sz="1800" kern="1200">
         <a:solidFill>
           <a:schemeClr val="tx1"/>
@@ -23,7 +25,7 @@
         <a:cs typeface="+mn-cs"/>
       </a:defRPr>
     </a:lvl1pPr>
-    <a:lvl2pPr marL="457200" algn="l" defTabSz="914400" rtl="0" eaLnBrk="1" latinLnBrk="0" hangingPunct="1">
+    <a:lvl2pPr marL="457200" algn="l" defTabSz="457200" rtl="0" eaLnBrk="1" latinLnBrk="0" hangingPunct="1">
       <a:defRPr sz="1800" kern="1200">
         <a:solidFill>
           <a:schemeClr val="tx1"/>
@@ -33,7 +35,7 @@
         <a:cs typeface="+mn-cs"/>
       </a:defRPr>
     </a:lvl2pPr>
-    <a:lvl3pPr marL="914400" algn="l" defTabSz="914400" rtl="0" eaLnBrk="1" latinLnBrk="0" hangingPunct="1">
+    <a:lvl3pPr marL="914400" algn="l" defTabSz="457200" rtl="0" eaLnBrk="1" latinLnBrk="0" hangingPunct="1">
       <a:defRPr sz="1800" kern="1200">
         <a:solidFill>
           <a:schemeClr val="tx1"/>
@@ -43,7 +45,7 @@
         <a:cs typeface="+mn-cs"/>
       </a:defRPr>
     </a:lvl3pPr>
-    <a:lvl4pPr marL="1371600" algn="l" defTabSz="914400" rtl="0" eaLnBrk="1" latinLnBrk="0" hangingPunct="1">
+    <a:lvl4pPr marL="1371600" algn="l" defTabSz="457200" rtl="0" eaLnBrk="1" latinLnBrk="0" hangingPunct="1">
       <a:defRPr sz="1800" kern="1200">
         <a:solidFill>
           <a:schemeClr val="tx1"/>
@@ -53,7 +55,7 @@
         <a:cs typeface="+mn-cs"/>
       </a:defRPr>
     </a:lvl4pPr>
-    <a:lvl5pPr marL="1828800" algn="l" defTabSz="914400" rtl="0" eaLnBrk="1" latinLnBrk="0" hangingPunct="1">
+    <a:lvl5pPr marL="1828800" algn="l" defTabSz="457200" rtl="0" eaLnBrk="1" latinLnBrk="0" hangingPunct="1">
       <a:defRPr sz="1800" kern="1200">
         <a:solidFill>
           <a:schemeClr val="tx1"/>
@@ -63,7 +65,7 @@
         <a:cs typeface="+mn-cs"/>
       </a:defRPr>
     </a:lvl5pPr>
-    <a:lvl6pPr marL="2286000" algn="l" defTabSz="914400" rtl="0" eaLnBrk="1" latinLnBrk="0" hangingPunct="1">
+    <a:lvl6pPr marL="2286000" algn="l" defTabSz="457200" rtl="0" eaLnBrk="1" latinLnBrk="0" hangingPunct="1">
       <a:defRPr sz="1800" kern="1200">
         <a:solidFill>
           <a:schemeClr val="tx1"/>
@@ -73,7 +75,7 @@
         <a:cs typeface="+mn-cs"/>
       </a:defRPr>
     </a:lvl6pPr>
-    <a:lvl7pPr marL="2743200" algn="l" defTabSz="914400" rtl="0" eaLnBrk="1" latinLnBrk="0" hangingPunct="1">
+    <a:lvl7pPr marL="2743200" algn="l" defTabSz="457200" rtl="0" eaLnBrk="1" latinLnBrk="0" hangingPunct="1">
       <a:defRPr sz="1800" kern="1200">
         <a:solidFill>
           <a:schemeClr val="tx1"/>
@@ -83,7 +85,7 @@
         <a:cs typeface="+mn-cs"/>
       </a:defRPr>
     </a:lvl7pPr>
-    <a:lvl8pPr marL="3200400" algn="l" defTabSz="914400" rtl="0" eaLnBrk="1" latinLnBrk="0" hangingPunct="1">
+    <a:lvl8pPr marL="3200400" algn="l" defTabSz="457200" rtl="0" eaLnBrk="1" latinLnBrk="0" hangingPunct="1">
       <a:defRPr sz="1800" kern="1200">
         <a:solidFill>
           <a:schemeClr val="tx1"/>
@@ -93,7 +95,7 @@
         <a:cs typeface="+mn-cs"/>
       </a:defRPr>
     </a:lvl8pPr>
-    <a:lvl9pPr marL="3657600" algn="l" defTabSz="914400" rtl="0" eaLnBrk="1" latinLnBrk="0" hangingPunct="1">
+    <a:lvl9pPr marL="3657600" algn="l" defTabSz="457200" rtl="0" eaLnBrk="1" latinLnBrk="0" hangingPunct="1">
       <a:defRPr sz="1800" kern="1200">
         <a:solidFill>
           <a:schemeClr val="tx1"/>
@@ -104,6 +106,11 @@
       </a:defRPr>
     </a:lvl9pPr>
   </p:defaultTextStyle>
+  <p:extLst>
+    <p:ext uri="{EFAFB233-063F-42B5-8137-9DF3F51BA10A}">
+      <p15:sldGuideLst xmlns:p15="http://schemas.microsoft.com/office/powerpoint/2012/main"/>
+    </p:ext>
+  </p:extLst>
 </p:presentation>
 </file>
 
@@ -126,13 +133,7 @@
       </p:grpSpPr>
       <p:sp>
         <p:nvSpPr>
-          <p:cNvPr id="2" name="Title 1">
-            <a:extLst>
-              <a:ext uri="{FF2B5EF4-FFF2-40B4-BE49-F238E27FC236}">
-                <a16:creationId xmlns:a16="http://schemas.microsoft.com/office/drawing/2014/main" id="{25BD2D46-DF39-4355-9D45-974EE3312BA8}"/>
-              </a:ext>
-            </a:extLst>
-          </p:cNvPr>
+          <p:cNvPr id="2" name="Title 1"/>
           <p:cNvSpPr>
             <a:spLocks noGrp="1"/>
           </p:cNvSpPr>
@@ -142,8 +143,8 @@
         </p:nvSpPr>
         <p:spPr>
           <a:xfrm>
-            <a:off x="1524000" y="1122363"/>
-            <a:ext cx="9144000" cy="2387600"/>
+            <a:off x="685800" y="1122363"/>
+            <a:ext cx="7772400" cy="2387600"/>
           </a:xfrm>
         </p:spPr>
         <p:txBody>
@@ -158,19 +159,13 @@
               <a:rPr lang="en-US"/>
               <a:t>Click to edit Master title style</a:t>
             </a:r>
-            <a:endParaRPr lang="en-GB"/>
-          </a:p>
-        </p:txBody>
-      </p:sp>
-      <p:sp>
-        <p:nvSpPr>
-          <p:cNvPr id="3" name="Subtitle 2">
-            <a:extLst>
-              <a:ext uri="{FF2B5EF4-FFF2-40B4-BE49-F238E27FC236}">
-                <a16:creationId xmlns:a16="http://schemas.microsoft.com/office/drawing/2014/main" id="{60A8EBF2-7EE3-453F-8392-88DB52361759}"/>
-              </a:ext>
-            </a:extLst>
-          </p:cNvPr>
+            <a:endParaRPr lang="en-US" dirty="0"/>
+          </a:p>
+        </p:txBody>
+      </p:sp>
+      <p:sp>
+        <p:nvSpPr>
+          <p:cNvPr id="3" name="Subtitle 2"/>
           <p:cNvSpPr>
             <a:spLocks noGrp="1"/>
           </p:cNvSpPr>
@@ -180,8 +175,8 @@
         </p:nvSpPr>
         <p:spPr>
           <a:xfrm>
-            <a:off x="1524000" y="3602038"/>
-            <a:ext cx="9144000" cy="1655762"/>
+            <a:off x="1143000" y="3602038"/>
+            <a:ext cx="6858000" cy="1655762"/>
           </a:xfrm>
         </p:spPr>
         <p:txBody>
@@ -229,19 +224,13 @@
               <a:rPr lang="en-US"/>
               <a:t>Click to edit Master subtitle style</a:t>
             </a:r>
-            <a:endParaRPr lang="en-GB"/>
-          </a:p>
-        </p:txBody>
-      </p:sp>
-      <p:sp>
-        <p:nvSpPr>
-          <p:cNvPr id="4" name="Date Placeholder 3">
-            <a:extLst>
-              <a:ext uri="{FF2B5EF4-FFF2-40B4-BE49-F238E27FC236}">
-                <a16:creationId xmlns:a16="http://schemas.microsoft.com/office/drawing/2014/main" id="{D4B6AE01-473F-4743-8FAD-9B4BB075F8CD}"/>
-              </a:ext>
-            </a:extLst>
-          </p:cNvPr>
+            <a:endParaRPr lang="en-US" dirty="0"/>
+          </a:p>
+        </p:txBody>
+      </p:sp>
+      <p:sp>
+        <p:nvSpPr>
+          <p:cNvPr id="4" name="Date Placeholder 3"/>
           <p:cNvSpPr>
             <a:spLocks noGrp="1"/>
           </p:cNvSpPr>
@@ -256,7 +245,7 @@
           <a:p>
             <a:fld id="{8AE970B3-99CF-4010-BD22-8A76CE724EA0}" type="datetimeFigureOut">
               <a:rPr lang="en-GB" smtClean="0"/>
-              <a:t>04/03/2026</a:t>
+              <a:t>01/04/2026</a:t>
             </a:fld>
             <a:endParaRPr lang="en-GB"/>
           </a:p>
@@ -264,13 +253,7 @@
       </p:sp>
       <p:sp>
         <p:nvSpPr>
-          <p:cNvPr id="5" name="Footer Placeholder 4">
-            <a:extLst>
-              <a:ext uri="{FF2B5EF4-FFF2-40B4-BE49-F238E27FC236}">
-                <a16:creationId xmlns:a16="http://schemas.microsoft.com/office/drawing/2014/main" id="{E5D1E15C-5E56-4140-B502-9E967FC4F534}"/>
-              </a:ext>
-            </a:extLst>
-          </p:cNvPr>
+          <p:cNvPr id="5" name="Footer Placeholder 4"/>
           <p:cNvSpPr>
             <a:spLocks noGrp="1"/>
           </p:cNvSpPr>
@@ -289,13 +272,7 @@
       </p:sp>
       <p:sp>
         <p:nvSpPr>
-          <p:cNvPr id="6" name="Slide Number Placeholder 5">
-            <a:extLst>
-              <a:ext uri="{FF2B5EF4-FFF2-40B4-BE49-F238E27FC236}">
-                <a16:creationId xmlns:a16="http://schemas.microsoft.com/office/drawing/2014/main" id="{4278FE33-E727-4F57-BA4C-13B834902BE8}"/>
-              </a:ext>
-            </a:extLst>
-          </p:cNvPr>
+          <p:cNvPr id="6" name="Slide Number Placeholder 5"/>
           <p:cNvSpPr>
             <a:spLocks noGrp="1"/>
           </p:cNvSpPr>
@@ -319,7 +296,7 @@
     </p:spTree>
     <p:extLst>
       <p:ext uri="{BB962C8B-B14F-4D97-AF65-F5344CB8AC3E}">
-        <p14:creationId xmlns:p14="http://schemas.microsoft.com/office/powerpoint/2010/main" val="4102823131"/>
+        <p14:creationId xmlns:p14="http://schemas.microsoft.com/office/powerpoint/2010/main" val="1650359418"/>
       </p:ext>
     </p:extLst>
   </p:cSld>
@@ -348,13 +325,7 @@
       </p:grpSpPr>
       <p:sp>
         <p:nvSpPr>
-          <p:cNvPr id="2" name="Title 1">
-            <a:extLst>
-              <a:ext uri="{FF2B5EF4-FFF2-40B4-BE49-F238E27FC236}">
-                <a16:creationId xmlns:a16="http://schemas.microsoft.com/office/drawing/2014/main" id="{575DD141-D9BB-48EF-AD3A-9ACFCCC1CD0B}"/>
-              </a:ext>
-            </a:extLst>
-          </p:cNvPr>
+          <p:cNvPr id="2" name="Title 1"/>
           <p:cNvSpPr>
             <a:spLocks noGrp="1"/>
           </p:cNvSpPr>
@@ -371,19 +342,13 @@
               <a:rPr lang="en-US"/>
               <a:t>Click to edit Master title style</a:t>
             </a:r>
-            <a:endParaRPr lang="en-GB"/>
-          </a:p>
-        </p:txBody>
-      </p:sp>
-      <p:sp>
-        <p:nvSpPr>
-          <p:cNvPr id="3" name="Vertical Text Placeholder 2">
-            <a:extLst>
-              <a:ext uri="{FF2B5EF4-FFF2-40B4-BE49-F238E27FC236}">
-                <a16:creationId xmlns:a16="http://schemas.microsoft.com/office/drawing/2014/main" id="{0ED3A51B-62DA-4A6D-A513-023FC87D8484}"/>
-              </a:ext>
-            </a:extLst>
-          </p:cNvPr>
+            <a:endParaRPr lang="en-US" dirty="0"/>
+          </a:p>
+        </p:txBody>
+      </p:sp>
+      <p:sp>
+        <p:nvSpPr>
+          <p:cNvPr id="3" name="Vertical Text Placeholder 2"/>
           <p:cNvSpPr>
             <a:spLocks noGrp="1"/>
           </p:cNvSpPr>
@@ -429,19 +394,13 @@
               <a:rPr lang="en-US"/>
               <a:t>Fifth level</a:t>
             </a:r>
-            <a:endParaRPr lang="en-GB"/>
-          </a:p>
-        </p:txBody>
-      </p:sp>
-      <p:sp>
-        <p:nvSpPr>
-          <p:cNvPr id="4" name="Date Placeholder 3">
-            <a:extLst>
-              <a:ext uri="{FF2B5EF4-FFF2-40B4-BE49-F238E27FC236}">
-                <a16:creationId xmlns:a16="http://schemas.microsoft.com/office/drawing/2014/main" id="{1DC06F0E-96D1-48A8-9FAB-C7F14B5E10DA}"/>
-              </a:ext>
-            </a:extLst>
-          </p:cNvPr>
+            <a:endParaRPr lang="en-US" dirty="0"/>
+          </a:p>
+        </p:txBody>
+      </p:sp>
+      <p:sp>
+        <p:nvSpPr>
+          <p:cNvPr id="4" name="Date Placeholder 3"/>
           <p:cNvSpPr>
             <a:spLocks noGrp="1"/>
           </p:cNvSpPr>
@@ -456,7 +415,7 @@
           <a:p>
             <a:fld id="{8AE970B3-99CF-4010-BD22-8A76CE724EA0}" type="datetimeFigureOut">
               <a:rPr lang="en-GB" smtClean="0"/>
-              <a:t>04/03/2026</a:t>
+              <a:t>01/04/2026</a:t>
             </a:fld>
             <a:endParaRPr lang="en-GB"/>
           </a:p>
@@ -464,13 +423,7 @@
       </p:sp>
       <p:sp>
         <p:nvSpPr>
-          <p:cNvPr id="5" name="Footer Placeholder 4">
-            <a:extLst>
-              <a:ext uri="{FF2B5EF4-FFF2-40B4-BE49-F238E27FC236}">
-                <a16:creationId xmlns:a16="http://schemas.microsoft.com/office/drawing/2014/main" id="{D1B3B9F8-646A-416D-AAD0-2F39541FB589}"/>
-              </a:ext>
-            </a:extLst>
-          </p:cNvPr>
+          <p:cNvPr id="5" name="Footer Placeholder 4"/>
           <p:cNvSpPr>
             <a:spLocks noGrp="1"/>
           </p:cNvSpPr>
@@ -489,13 +442,7 @@
       </p:sp>
       <p:sp>
         <p:nvSpPr>
-          <p:cNvPr id="6" name="Slide Number Placeholder 5">
-            <a:extLst>
-              <a:ext uri="{FF2B5EF4-FFF2-40B4-BE49-F238E27FC236}">
-                <a16:creationId xmlns:a16="http://schemas.microsoft.com/office/drawing/2014/main" id="{F10DE68E-463C-4D69-93A7-F8FB48F2A520}"/>
-              </a:ext>
-            </a:extLst>
-          </p:cNvPr>
+          <p:cNvPr id="6" name="Slide Number Placeholder 5"/>
           <p:cNvSpPr>
             <a:spLocks noGrp="1"/>
           </p:cNvSpPr>
@@ -519,7 +466,7 @@
     </p:spTree>
     <p:extLst>
       <p:ext uri="{BB962C8B-B14F-4D97-AF65-F5344CB8AC3E}">
-        <p14:creationId xmlns:p14="http://schemas.microsoft.com/office/powerpoint/2010/main" val="3863224571"/>
+        <p14:creationId xmlns:p14="http://schemas.microsoft.com/office/powerpoint/2010/main" val="673466361"/>
       </p:ext>
     </p:extLst>
   </p:cSld>
@@ -548,13 +495,7 @@
       </p:grpSpPr>
       <p:sp>
         <p:nvSpPr>
-          <p:cNvPr id="2" name="Vertical Title 1">
-            <a:extLst>
-              <a:ext uri="{FF2B5EF4-FFF2-40B4-BE49-F238E27FC236}">
-                <a16:creationId xmlns:a16="http://schemas.microsoft.com/office/drawing/2014/main" id="{63DCB13F-F8CD-47AA-9C54-06A5ABE6BC67}"/>
-              </a:ext>
-            </a:extLst>
-          </p:cNvPr>
+          <p:cNvPr id="2" name="Vertical Title 1"/>
           <p:cNvSpPr>
             <a:spLocks noGrp="1"/>
           </p:cNvSpPr>
@@ -564,8 +505,8 @@
         </p:nvSpPr>
         <p:spPr>
           <a:xfrm>
-            <a:off x="8724900" y="365125"/>
-            <a:ext cx="2628900" cy="5811838"/>
+            <a:off x="6543675" y="365125"/>
+            <a:ext cx="1971675" cy="5811838"/>
           </a:xfrm>
         </p:spPr>
         <p:txBody>
@@ -576,19 +517,13 @@
               <a:rPr lang="en-US"/>
               <a:t>Click to edit Master title style</a:t>
             </a:r>
-            <a:endParaRPr lang="en-GB"/>
-          </a:p>
-        </p:txBody>
-      </p:sp>
-      <p:sp>
-        <p:nvSpPr>
-          <p:cNvPr id="3" name="Vertical Text Placeholder 2">
-            <a:extLst>
-              <a:ext uri="{FF2B5EF4-FFF2-40B4-BE49-F238E27FC236}">
-                <a16:creationId xmlns:a16="http://schemas.microsoft.com/office/drawing/2014/main" id="{4F5D3CDB-AAA3-4F88-AFD1-096105B80B47}"/>
-              </a:ext>
-            </a:extLst>
-          </p:cNvPr>
+            <a:endParaRPr lang="en-US" dirty="0"/>
+          </a:p>
+        </p:txBody>
+      </p:sp>
+      <p:sp>
+        <p:nvSpPr>
+          <p:cNvPr id="3" name="Vertical Text Placeholder 2"/>
           <p:cNvSpPr>
             <a:spLocks noGrp="1"/>
           </p:cNvSpPr>
@@ -598,8 +533,8 @@
         </p:nvSpPr>
         <p:spPr>
           <a:xfrm>
-            <a:off x="838200" y="365125"/>
-            <a:ext cx="7734300" cy="5811838"/>
+            <a:off x="628650" y="365125"/>
+            <a:ext cx="5800725" cy="5811838"/>
           </a:xfrm>
         </p:spPr>
         <p:txBody>
@@ -639,19 +574,13 @@
               <a:rPr lang="en-US"/>
               <a:t>Fifth level</a:t>
             </a:r>
-            <a:endParaRPr lang="en-GB"/>
-          </a:p>
-        </p:txBody>
-      </p:sp>
-      <p:sp>
-        <p:nvSpPr>
-          <p:cNvPr id="4" name="Date Placeholder 3">
-            <a:extLst>
-              <a:ext uri="{FF2B5EF4-FFF2-40B4-BE49-F238E27FC236}">
-                <a16:creationId xmlns:a16="http://schemas.microsoft.com/office/drawing/2014/main" id="{D67AAE9B-473D-4F7E-9D5C-3485CCC98179}"/>
-              </a:ext>
-            </a:extLst>
-          </p:cNvPr>
+            <a:endParaRPr lang="en-US" dirty="0"/>
+          </a:p>
+        </p:txBody>
+      </p:sp>
+      <p:sp>
+        <p:nvSpPr>
+          <p:cNvPr id="4" name="Date Placeholder 3"/>
           <p:cNvSpPr>
             <a:spLocks noGrp="1"/>
           </p:cNvSpPr>
@@ -666,7 +595,7 @@
           <a:p>
             <a:fld id="{8AE970B3-99CF-4010-BD22-8A76CE724EA0}" type="datetimeFigureOut">
               <a:rPr lang="en-GB" smtClean="0"/>
-              <a:t>04/03/2026</a:t>
+              <a:t>01/04/2026</a:t>
             </a:fld>
             <a:endParaRPr lang="en-GB"/>
           </a:p>
@@ -674,13 +603,7 @@
       </p:sp>
       <p:sp>
         <p:nvSpPr>
-          <p:cNvPr id="5" name="Footer Placeholder 4">
-            <a:extLst>
-              <a:ext uri="{FF2B5EF4-FFF2-40B4-BE49-F238E27FC236}">
-                <a16:creationId xmlns:a16="http://schemas.microsoft.com/office/drawing/2014/main" id="{F4D11316-EB32-4CE9-BD4A-5ED09673977A}"/>
-              </a:ext>
-            </a:extLst>
-          </p:cNvPr>
+          <p:cNvPr id="5" name="Footer Placeholder 4"/>
           <p:cNvSpPr>
             <a:spLocks noGrp="1"/>
           </p:cNvSpPr>
@@ -699,13 +622,7 @@
       </p:sp>
       <p:sp>
         <p:nvSpPr>
-          <p:cNvPr id="6" name="Slide Number Placeholder 5">
-            <a:extLst>
-              <a:ext uri="{FF2B5EF4-FFF2-40B4-BE49-F238E27FC236}">
-                <a16:creationId xmlns:a16="http://schemas.microsoft.com/office/drawing/2014/main" id="{4940103F-E11B-4344-9D02-E894CF9101D9}"/>
-              </a:ext>
-            </a:extLst>
-          </p:cNvPr>
+          <p:cNvPr id="6" name="Slide Number Placeholder 5"/>
           <p:cNvSpPr>
             <a:spLocks noGrp="1"/>
           </p:cNvSpPr>
@@ -729,7 +646,7 @@
     </p:spTree>
     <p:extLst>
       <p:ext uri="{BB962C8B-B14F-4D97-AF65-F5344CB8AC3E}">
-        <p14:creationId xmlns:p14="http://schemas.microsoft.com/office/powerpoint/2010/main" val="933065634"/>
+        <p14:creationId xmlns:p14="http://schemas.microsoft.com/office/powerpoint/2010/main" val="3273552082"/>
       </p:ext>
     </p:extLst>
   </p:cSld>
@@ -758,13 +675,7 @@
       </p:grpSpPr>
       <p:sp>
         <p:nvSpPr>
-          <p:cNvPr id="2" name="Title 1">
-            <a:extLst>
-              <a:ext uri="{FF2B5EF4-FFF2-40B4-BE49-F238E27FC236}">
-                <a16:creationId xmlns:a16="http://schemas.microsoft.com/office/drawing/2014/main" id="{E4CBE6F5-54F6-4557-A818-8FB920E5B68B}"/>
-              </a:ext>
-            </a:extLst>
-          </p:cNvPr>
+          <p:cNvPr id="2" name="Title 1"/>
           <p:cNvSpPr>
             <a:spLocks noGrp="1"/>
           </p:cNvSpPr>
@@ -781,19 +692,13 @@
               <a:rPr lang="en-US"/>
               <a:t>Click to edit Master title style</a:t>
             </a:r>
-            <a:endParaRPr lang="en-GB"/>
-          </a:p>
-        </p:txBody>
-      </p:sp>
-      <p:sp>
-        <p:nvSpPr>
-          <p:cNvPr id="3" name="Content Placeholder 2">
-            <a:extLst>
-              <a:ext uri="{FF2B5EF4-FFF2-40B4-BE49-F238E27FC236}">
-                <a16:creationId xmlns:a16="http://schemas.microsoft.com/office/drawing/2014/main" id="{B8307F4A-9BDA-4666-93D4-3CED8CFBA886}"/>
-              </a:ext>
-            </a:extLst>
-          </p:cNvPr>
+            <a:endParaRPr lang="en-US" dirty="0"/>
+          </a:p>
+        </p:txBody>
+      </p:sp>
+      <p:sp>
+        <p:nvSpPr>
+          <p:cNvPr id="3" name="Content Placeholder 2"/>
           <p:cNvSpPr>
             <a:spLocks noGrp="1"/>
           </p:cNvSpPr>
@@ -839,19 +744,13 @@
               <a:rPr lang="en-US"/>
               <a:t>Fifth level</a:t>
             </a:r>
-            <a:endParaRPr lang="en-GB"/>
-          </a:p>
-        </p:txBody>
-      </p:sp>
-      <p:sp>
-        <p:nvSpPr>
-          <p:cNvPr id="4" name="Date Placeholder 3">
-            <a:extLst>
-              <a:ext uri="{FF2B5EF4-FFF2-40B4-BE49-F238E27FC236}">
-                <a16:creationId xmlns:a16="http://schemas.microsoft.com/office/drawing/2014/main" id="{00324656-069D-4713-90B5-EE9AB07F2B19}"/>
-              </a:ext>
-            </a:extLst>
-          </p:cNvPr>
+            <a:endParaRPr lang="en-US" dirty="0"/>
+          </a:p>
+        </p:txBody>
+      </p:sp>
+      <p:sp>
+        <p:nvSpPr>
+          <p:cNvPr id="4" name="Date Placeholder 3"/>
           <p:cNvSpPr>
             <a:spLocks noGrp="1"/>
           </p:cNvSpPr>
@@ -866,7 +765,7 @@
           <a:p>
             <a:fld id="{8AE970B3-99CF-4010-BD22-8A76CE724EA0}" type="datetimeFigureOut">
               <a:rPr lang="en-GB" smtClean="0"/>
-              <a:t>04/03/2026</a:t>
+              <a:t>01/04/2026</a:t>
             </a:fld>
             <a:endParaRPr lang="en-GB"/>
           </a:p>
@@ -874,13 +773,7 @@
       </p:sp>
       <p:sp>
         <p:nvSpPr>
-          <p:cNvPr id="5" name="Footer Placeholder 4">
-            <a:extLst>
-              <a:ext uri="{FF2B5EF4-FFF2-40B4-BE49-F238E27FC236}">
-                <a16:creationId xmlns:a16="http://schemas.microsoft.com/office/drawing/2014/main" id="{48414C3D-1158-4260-9FE3-E664370853B5}"/>
-              </a:ext>
-            </a:extLst>
-          </p:cNvPr>
+          <p:cNvPr id="5" name="Footer Placeholder 4"/>
           <p:cNvSpPr>
             <a:spLocks noGrp="1"/>
           </p:cNvSpPr>
@@ -899,13 +792,7 @@
       </p:sp>
       <p:sp>
         <p:nvSpPr>
-          <p:cNvPr id="6" name="Slide Number Placeholder 5">
-            <a:extLst>
-              <a:ext uri="{FF2B5EF4-FFF2-40B4-BE49-F238E27FC236}">
-                <a16:creationId xmlns:a16="http://schemas.microsoft.com/office/drawing/2014/main" id="{0E0E3643-47FC-4396-BA73-61F6A143A70D}"/>
-              </a:ext>
-            </a:extLst>
-          </p:cNvPr>
+          <p:cNvPr id="6" name="Slide Number Placeholder 5"/>
           <p:cNvSpPr>
             <a:spLocks noGrp="1"/>
           </p:cNvSpPr>
@@ -929,7 +816,7 @@
     </p:spTree>
     <p:extLst>
       <p:ext uri="{BB962C8B-B14F-4D97-AF65-F5344CB8AC3E}">
-        <p14:creationId xmlns:p14="http://schemas.microsoft.com/office/powerpoint/2010/main" val="231294275"/>
+        <p14:creationId xmlns:p14="http://schemas.microsoft.com/office/powerpoint/2010/main" val="2766710833"/>
       </p:ext>
     </p:extLst>
   </p:cSld>
@@ -958,13 +845,7 @@
       </p:grpSpPr>
       <p:sp>
         <p:nvSpPr>
-          <p:cNvPr id="2" name="Title 1">
-            <a:extLst>
-              <a:ext uri="{FF2B5EF4-FFF2-40B4-BE49-F238E27FC236}">
-                <a16:creationId xmlns:a16="http://schemas.microsoft.com/office/drawing/2014/main" id="{8521E6A4-769C-455F-B945-A4906FC787CF}"/>
-              </a:ext>
-            </a:extLst>
-          </p:cNvPr>
+          <p:cNvPr id="2" name="Title 1"/>
           <p:cNvSpPr>
             <a:spLocks noGrp="1"/>
           </p:cNvSpPr>
@@ -974,8 +855,8 @@
         </p:nvSpPr>
         <p:spPr>
           <a:xfrm>
-            <a:off x="831850" y="1709738"/>
-            <a:ext cx="10515600" cy="2852737"/>
+            <a:off x="623888" y="1709739"/>
+            <a:ext cx="7886700" cy="2852737"/>
           </a:xfrm>
         </p:spPr>
         <p:txBody>
@@ -990,19 +871,13 @@
               <a:rPr lang="en-US"/>
               <a:t>Click to edit Master title style</a:t>
             </a:r>
-            <a:endParaRPr lang="en-GB"/>
-          </a:p>
-        </p:txBody>
-      </p:sp>
-      <p:sp>
-        <p:nvSpPr>
-          <p:cNvPr id="3" name="Text Placeholder 2">
-            <a:extLst>
-              <a:ext uri="{FF2B5EF4-FFF2-40B4-BE49-F238E27FC236}">
-                <a16:creationId xmlns:a16="http://schemas.microsoft.com/office/drawing/2014/main" id="{2A445D43-E6A6-4111-8EEE-224C43F7CE54}"/>
-              </a:ext>
-            </a:extLst>
-          </p:cNvPr>
+            <a:endParaRPr lang="en-US" dirty="0"/>
+          </a:p>
+        </p:txBody>
+      </p:sp>
+      <p:sp>
+        <p:nvSpPr>
+          <p:cNvPr id="3" name="Text Placeholder 2"/>
           <p:cNvSpPr>
             <a:spLocks noGrp="1"/>
           </p:cNvSpPr>
@@ -1012,8 +887,8 @@
         </p:nvSpPr>
         <p:spPr>
           <a:xfrm>
-            <a:off x="831850" y="4589463"/>
-            <a:ext cx="10515600" cy="1500187"/>
+            <a:off x="623888" y="4589464"/>
+            <a:ext cx="7886700" cy="1500187"/>
           </a:xfrm>
         </p:spPr>
         <p:txBody>
@@ -1023,9 +898,7 @@
               <a:buNone/>
               <a:defRPr sz="2400">
                 <a:solidFill>
-                  <a:schemeClr val="tx1">
-                    <a:tint val="75000"/>
-                  </a:schemeClr>
+                  <a:schemeClr val="tx1"/>
                 </a:solidFill>
               </a:defRPr>
             </a:lvl1pPr>
@@ -1121,13 +994,7 @@
       </p:sp>
       <p:sp>
         <p:nvSpPr>
-          <p:cNvPr id="4" name="Date Placeholder 3">
-            <a:extLst>
-              <a:ext uri="{FF2B5EF4-FFF2-40B4-BE49-F238E27FC236}">
-                <a16:creationId xmlns:a16="http://schemas.microsoft.com/office/drawing/2014/main" id="{762DD240-0F1F-4524-B737-F06E3C6B2997}"/>
-              </a:ext>
-            </a:extLst>
-          </p:cNvPr>
+          <p:cNvPr id="4" name="Date Placeholder 3"/>
           <p:cNvSpPr>
             <a:spLocks noGrp="1"/>
           </p:cNvSpPr>
@@ -1142,7 +1009,7 @@
           <a:p>
             <a:fld id="{8AE970B3-99CF-4010-BD22-8A76CE724EA0}" type="datetimeFigureOut">
               <a:rPr lang="en-GB" smtClean="0"/>
-              <a:t>04/03/2026</a:t>
+              <a:t>01/04/2026</a:t>
             </a:fld>
             <a:endParaRPr lang="en-GB"/>
           </a:p>
@@ -1150,13 +1017,7 @@
       </p:sp>
       <p:sp>
         <p:nvSpPr>
-          <p:cNvPr id="5" name="Footer Placeholder 4">
-            <a:extLst>
-              <a:ext uri="{FF2B5EF4-FFF2-40B4-BE49-F238E27FC236}">
-                <a16:creationId xmlns:a16="http://schemas.microsoft.com/office/drawing/2014/main" id="{3270FBCA-C58D-4559-A71D-D8581C6B2D95}"/>
-              </a:ext>
-            </a:extLst>
-          </p:cNvPr>
+          <p:cNvPr id="5" name="Footer Placeholder 4"/>
           <p:cNvSpPr>
             <a:spLocks noGrp="1"/>
           </p:cNvSpPr>
@@ -1175,13 +1036,7 @@
       </p:sp>
       <p:sp>
         <p:nvSpPr>
-          <p:cNvPr id="6" name="Slide Number Placeholder 5">
-            <a:extLst>
-              <a:ext uri="{FF2B5EF4-FFF2-40B4-BE49-F238E27FC236}">
-                <a16:creationId xmlns:a16="http://schemas.microsoft.com/office/drawing/2014/main" id="{E397F438-2282-4BE5-8AD6-62724411171B}"/>
-              </a:ext>
-            </a:extLst>
-          </p:cNvPr>
+          <p:cNvPr id="6" name="Slide Number Placeholder 5"/>
           <p:cNvSpPr>
             <a:spLocks noGrp="1"/>
           </p:cNvSpPr>
@@ -1205,7 +1060,7 @@
     </p:spTree>
     <p:extLst>
       <p:ext uri="{BB962C8B-B14F-4D97-AF65-F5344CB8AC3E}">
-        <p14:creationId xmlns:p14="http://schemas.microsoft.com/office/powerpoint/2010/main" val="3424355884"/>
+        <p14:creationId xmlns:p14="http://schemas.microsoft.com/office/powerpoint/2010/main" val="3762567966"/>
       </p:ext>
     </p:extLst>
   </p:cSld>
@@ -1234,13 +1089,7 @@
       </p:grpSpPr>
       <p:sp>
         <p:nvSpPr>
-          <p:cNvPr id="2" name="Title 1">
-            <a:extLst>
-              <a:ext uri="{FF2B5EF4-FFF2-40B4-BE49-F238E27FC236}">
-                <a16:creationId xmlns:a16="http://schemas.microsoft.com/office/drawing/2014/main" id="{1BAA3B4D-0282-4516-8A34-B0329F097B10}"/>
-              </a:ext>
-            </a:extLst>
-          </p:cNvPr>
+          <p:cNvPr id="2" name="Title 1"/>
           <p:cNvSpPr>
             <a:spLocks noGrp="1"/>
           </p:cNvSpPr>
@@ -1257,19 +1106,13 @@
               <a:rPr lang="en-US"/>
               <a:t>Click to edit Master title style</a:t>
             </a:r>
-            <a:endParaRPr lang="en-GB"/>
-          </a:p>
-        </p:txBody>
-      </p:sp>
-      <p:sp>
-        <p:nvSpPr>
-          <p:cNvPr id="3" name="Content Placeholder 2">
-            <a:extLst>
-              <a:ext uri="{FF2B5EF4-FFF2-40B4-BE49-F238E27FC236}">
-                <a16:creationId xmlns:a16="http://schemas.microsoft.com/office/drawing/2014/main" id="{446329BB-CE5E-4614-84DC-3E8D89AE162C}"/>
-              </a:ext>
-            </a:extLst>
-          </p:cNvPr>
+            <a:endParaRPr lang="en-US" dirty="0"/>
+          </a:p>
+        </p:txBody>
+      </p:sp>
+      <p:sp>
+        <p:nvSpPr>
+          <p:cNvPr id="3" name="Content Placeholder 2"/>
           <p:cNvSpPr>
             <a:spLocks noGrp="1"/>
           </p:cNvSpPr>
@@ -1279,8 +1122,8 @@
         </p:nvSpPr>
         <p:spPr>
           <a:xfrm>
-            <a:off x="838200" y="1825625"/>
-            <a:ext cx="5181600" cy="4351338"/>
+            <a:off x="628650" y="1825625"/>
+            <a:ext cx="3886200" cy="4351338"/>
           </a:xfrm>
         </p:spPr>
         <p:txBody>
@@ -1320,19 +1163,13 @@
               <a:rPr lang="en-US"/>
               <a:t>Fifth level</a:t>
             </a:r>
-            <a:endParaRPr lang="en-GB"/>
-          </a:p>
-        </p:txBody>
-      </p:sp>
-      <p:sp>
-        <p:nvSpPr>
-          <p:cNvPr id="4" name="Content Placeholder 3">
-            <a:extLst>
-              <a:ext uri="{FF2B5EF4-FFF2-40B4-BE49-F238E27FC236}">
-                <a16:creationId xmlns:a16="http://schemas.microsoft.com/office/drawing/2014/main" id="{C5983D45-C4C5-4EC9-8720-537B163293B8}"/>
-              </a:ext>
-            </a:extLst>
-          </p:cNvPr>
+            <a:endParaRPr lang="en-US" dirty="0"/>
+          </a:p>
+        </p:txBody>
+      </p:sp>
+      <p:sp>
+        <p:nvSpPr>
+          <p:cNvPr id="4" name="Content Placeholder 3"/>
           <p:cNvSpPr>
             <a:spLocks noGrp="1"/>
           </p:cNvSpPr>
@@ -1342,8 +1179,8 @@
         </p:nvSpPr>
         <p:spPr>
           <a:xfrm>
-            <a:off x="6172200" y="1825625"/>
-            <a:ext cx="5181600" cy="4351338"/>
+            <a:off x="4629150" y="1825625"/>
+            <a:ext cx="3886200" cy="4351338"/>
           </a:xfrm>
         </p:spPr>
         <p:txBody>
@@ -1383,19 +1220,13 @@
               <a:rPr lang="en-US"/>
               <a:t>Fifth level</a:t>
             </a:r>
-            <a:endParaRPr lang="en-GB"/>
-          </a:p>
-        </p:txBody>
-      </p:sp>
-      <p:sp>
-        <p:nvSpPr>
-          <p:cNvPr id="5" name="Date Placeholder 4">
-            <a:extLst>
-              <a:ext uri="{FF2B5EF4-FFF2-40B4-BE49-F238E27FC236}">
-                <a16:creationId xmlns:a16="http://schemas.microsoft.com/office/drawing/2014/main" id="{1D7A584B-8312-4D9C-913A-71CF2344330B}"/>
-              </a:ext>
-            </a:extLst>
-          </p:cNvPr>
+            <a:endParaRPr lang="en-US" dirty="0"/>
+          </a:p>
+        </p:txBody>
+      </p:sp>
+      <p:sp>
+        <p:nvSpPr>
+          <p:cNvPr id="5" name="Date Placeholder 4"/>
           <p:cNvSpPr>
             <a:spLocks noGrp="1"/>
           </p:cNvSpPr>
@@ -1410,7 +1241,7 @@
           <a:p>
             <a:fld id="{8AE970B3-99CF-4010-BD22-8A76CE724EA0}" type="datetimeFigureOut">
               <a:rPr lang="en-GB" smtClean="0"/>
-              <a:t>04/03/2026</a:t>
+              <a:t>01/04/2026</a:t>
             </a:fld>
             <a:endParaRPr lang="en-GB"/>
           </a:p>
@@ -1418,13 +1249,7 @@
       </p:sp>
       <p:sp>
         <p:nvSpPr>
-          <p:cNvPr id="6" name="Footer Placeholder 5">
-            <a:extLst>
-              <a:ext uri="{FF2B5EF4-FFF2-40B4-BE49-F238E27FC236}">
-                <a16:creationId xmlns:a16="http://schemas.microsoft.com/office/drawing/2014/main" id="{62569F69-50DF-4B8C-9086-0421719B6601}"/>
-              </a:ext>
-            </a:extLst>
-          </p:cNvPr>
+          <p:cNvPr id="6" name="Footer Placeholder 5"/>
           <p:cNvSpPr>
             <a:spLocks noGrp="1"/>
           </p:cNvSpPr>
@@ -1443,13 +1268,7 @@
       </p:sp>
       <p:sp>
         <p:nvSpPr>
-          <p:cNvPr id="7" name="Slide Number Placeholder 6">
-            <a:extLst>
-              <a:ext uri="{FF2B5EF4-FFF2-40B4-BE49-F238E27FC236}">
-                <a16:creationId xmlns:a16="http://schemas.microsoft.com/office/drawing/2014/main" id="{9EF81547-3B79-44FF-9214-75BB28ED321F}"/>
-              </a:ext>
-            </a:extLst>
-          </p:cNvPr>
+          <p:cNvPr id="7" name="Slide Number Placeholder 6"/>
           <p:cNvSpPr>
             <a:spLocks noGrp="1"/>
           </p:cNvSpPr>
@@ -1473,7 +1292,7 @@
     </p:spTree>
     <p:extLst>
       <p:ext uri="{BB962C8B-B14F-4D97-AF65-F5344CB8AC3E}">
-        <p14:creationId xmlns:p14="http://schemas.microsoft.com/office/powerpoint/2010/main" val="3848212791"/>
+        <p14:creationId xmlns:p14="http://schemas.microsoft.com/office/powerpoint/2010/main" val="2526199159"/>
       </p:ext>
     </p:extLst>
   </p:cSld>
@@ -1502,13 +1321,7 @@
       </p:grpSpPr>
       <p:sp>
         <p:nvSpPr>
-          <p:cNvPr id="2" name="Title 1">
-            <a:extLst>
-              <a:ext uri="{FF2B5EF4-FFF2-40B4-BE49-F238E27FC236}">
-                <a16:creationId xmlns:a16="http://schemas.microsoft.com/office/drawing/2014/main" id="{F3812672-4BCA-4F79-8F68-5FF28AF3126A}"/>
-              </a:ext>
-            </a:extLst>
-          </p:cNvPr>
+          <p:cNvPr id="2" name="Title 1"/>
           <p:cNvSpPr>
             <a:spLocks noGrp="1"/>
           </p:cNvSpPr>
@@ -1518,8 +1331,8 @@
         </p:nvSpPr>
         <p:spPr>
           <a:xfrm>
-            <a:off x="839788" y="365125"/>
-            <a:ext cx="10515600" cy="1325563"/>
+            <a:off x="629841" y="365126"/>
+            <a:ext cx="7886700" cy="1325563"/>
           </a:xfrm>
         </p:spPr>
         <p:txBody>
@@ -1530,19 +1343,13 @@
               <a:rPr lang="en-US"/>
               <a:t>Click to edit Master title style</a:t>
             </a:r>
-            <a:endParaRPr lang="en-GB"/>
-          </a:p>
-        </p:txBody>
-      </p:sp>
-      <p:sp>
-        <p:nvSpPr>
-          <p:cNvPr id="3" name="Text Placeholder 2">
-            <a:extLst>
-              <a:ext uri="{FF2B5EF4-FFF2-40B4-BE49-F238E27FC236}">
-                <a16:creationId xmlns:a16="http://schemas.microsoft.com/office/drawing/2014/main" id="{61DAB7BB-D4DB-413C-AC68-67C2129E4708}"/>
-              </a:ext>
-            </a:extLst>
-          </p:cNvPr>
+            <a:endParaRPr lang="en-US" dirty="0"/>
+          </a:p>
+        </p:txBody>
+      </p:sp>
+      <p:sp>
+        <p:nvSpPr>
+          <p:cNvPr id="3" name="Text Placeholder 2"/>
           <p:cNvSpPr>
             <a:spLocks noGrp="1"/>
           </p:cNvSpPr>
@@ -1552,8 +1359,8 @@
         </p:nvSpPr>
         <p:spPr>
           <a:xfrm>
-            <a:off x="839788" y="1681163"/>
-            <a:ext cx="5157787" cy="823912"/>
+            <a:off x="629842" y="1681163"/>
+            <a:ext cx="3868340" cy="823912"/>
           </a:xfrm>
         </p:spPr>
         <p:txBody>
@@ -1607,13 +1414,7 @@
       </p:sp>
       <p:sp>
         <p:nvSpPr>
-          <p:cNvPr id="4" name="Content Placeholder 3">
-            <a:extLst>
-              <a:ext uri="{FF2B5EF4-FFF2-40B4-BE49-F238E27FC236}">
-                <a16:creationId xmlns:a16="http://schemas.microsoft.com/office/drawing/2014/main" id="{96678B6A-89C4-4385-9D27-3637CE0204A2}"/>
-              </a:ext>
-            </a:extLst>
-          </p:cNvPr>
+          <p:cNvPr id="4" name="Content Placeholder 3"/>
           <p:cNvSpPr>
             <a:spLocks noGrp="1"/>
           </p:cNvSpPr>
@@ -1623,8 +1424,8 @@
         </p:nvSpPr>
         <p:spPr>
           <a:xfrm>
-            <a:off x="839788" y="2505075"/>
-            <a:ext cx="5157787" cy="3684588"/>
+            <a:off x="629842" y="2505075"/>
+            <a:ext cx="3868340" cy="3684588"/>
           </a:xfrm>
         </p:spPr>
         <p:txBody>
@@ -1664,19 +1465,13 @@
               <a:rPr lang="en-US"/>
               <a:t>Fifth level</a:t>
             </a:r>
-            <a:endParaRPr lang="en-GB"/>
-          </a:p>
-        </p:txBody>
-      </p:sp>
-      <p:sp>
-        <p:nvSpPr>
-          <p:cNvPr id="5" name="Text Placeholder 4">
-            <a:extLst>
-              <a:ext uri="{FF2B5EF4-FFF2-40B4-BE49-F238E27FC236}">
-                <a16:creationId xmlns:a16="http://schemas.microsoft.com/office/drawing/2014/main" id="{EC2991ED-9F47-4A60-B35F-65506FAD91C3}"/>
-              </a:ext>
-            </a:extLst>
-          </p:cNvPr>
+            <a:endParaRPr lang="en-US" dirty="0"/>
+          </a:p>
+        </p:txBody>
+      </p:sp>
+      <p:sp>
+        <p:nvSpPr>
+          <p:cNvPr id="5" name="Text Placeholder 4"/>
           <p:cNvSpPr>
             <a:spLocks noGrp="1"/>
           </p:cNvSpPr>
@@ -1686,8 +1481,8 @@
         </p:nvSpPr>
         <p:spPr>
           <a:xfrm>
-            <a:off x="6172200" y="1681163"/>
-            <a:ext cx="5183188" cy="823912"/>
+            <a:off x="4629150" y="1681163"/>
+            <a:ext cx="3887391" cy="823912"/>
           </a:xfrm>
         </p:spPr>
         <p:txBody>
@@ -1741,13 +1536,7 @@
       </p:sp>
       <p:sp>
         <p:nvSpPr>
-          <p:cNvPr id="6" name="Content Placeholder 5">
-            <a:extLst>
-              <a:ext uri="{FF2B5EF4-FFF2-40B4-BE49-F238E27FC236}">
-                <a16:creationId xmlns:a16="http://schemas.microsoft.com/office/drawing/2014/main" id="{26F2315B-24B9-4F14-A697-C02210B38355}"/>
-              </a:ext>
-            </a:extLst>
-          </p:cNvPr>
+          <p:cNvPr id="6" name="Content Placeholder 5"/>
           <p:cNvSpPr>
             <a:spLocks noGrp="1"/>
           </p:cNvSpPr>
@@ -1757,8 +1546,8 @@
         </p:nvSpPr>
         <p:spPr>
           <a:xfrm>
-            <a:off x="6172200" y="2505075"/>
-            <a:ext cx="5183188" cy="3684588"/>
+            <a:off x="4629150" y="2505075"/>
+            <a:ext cx="3887391" cy="3684588"/>
           </a:xfrm>
         </p:spPr>
         <p:txBody>
@@ -1798,19 +1587,13 @@
               <a:rPr lang="en-US"/>
               <a:t>Fifth level</a:t>
             </a:r>
-            <a:endParaRPr lang="en-GB"/>
-          </a:p>
-        </p:txBody>
-      </p:sp>
-      <p:sp>
-        <p:nvSpPr>
-          <p:cNvPr id="7" name="Date Placeholder 6">
-            <a:extLst>
-              <a:ext uri="{FF2B5EF4-FFF2-40B4-BE49-F238E27FC236}">
-                <a16:creationId xmlns:a16="http://schemas.microsoft.com/office/drawing/2014/main" id="{462E719A-380A-4658-BD70-D9A093B5EFCF}"/>
-              </a:ext>
-            </a:extLst>
-          </p:cNvPr>
+            <a:endParaRPr lang="en-US" dirty="0"/>
+          </a:p>
+        </p:txBody>
+      </p:sp>
+      <p:sp>
+        <p:nvSpPr>
+          <p:cNvPr id="7" name="Date Placeholder 6"/>
           <p:cNvSpPr>
             <a:spLocks noGrp="1"/>
           </p:cNvSpPr>
@@ -1825,7 +1608,7 @@
           <a:p>
             <a:fld id="{8AE970B3-99CF-4010-BD22-8A76CE724EA0}" type="datetimeFigureOut">
               <a:rPr lang="en-GB" smtClean="0"/>
-              <a:t>04/03/2026</a:t>
+              <a:t>01/04/2026</a:t>
             </a:fld>
             <a:endParaRPr lang="en-GB"/>
           </a:p>
@@ -1833,13 +1616,7 @@
       </p:sp>
       <p:sp>
         <p:nvSpPr>
-          <p:cNvPr id="8" name="Footer Placeholder 7">
-            <a:extLst>
-              <a:ext uri="{FF2B5EF4-FFF2-40B4-BE49-F238E27FC236}">
-                <a16:creationId xmlns:a16="http://schemas.microsoft.com/office/drawing/2014/main" id="{D515C8E2-0AC0-4682-8A16-B3B5EA5882EB}"/>
-              </a:ext>
-            </a:extLst>
-          </p:cNvPr>
+          <p:cNvPr id="8" name="Footer Placeholder 7"/>
           <p:cNvSpPr>
             <a:spLocks noGrp="1"/>
           </p:cNvSpPr>
@@ -1858,13 +1635,7 @@
       </p:sp>
       <p:sp>
         <p:nvSpPr>
-          <p:cNvPr id="9" name="Slide Number Placeholder 8">
-            <a:extLst>
-              <a:ext uri="{FF2B5EF4-FFF2-40B4-BE49-F238E27FC236}">
-                <a16:creationId xmlns:a16="http://schemas.microsoft.com/office/drawing/2014/main" id="{0C9EEAF5-EF4E-42AB-8C29-092059DE9626}"/>
-              </a:ext>
-            </a:extLst>
-          </p:cNvPr>
+          <p:cNvPr id="9" name="Slide Number Placeholder 8"/>
           <p:cNvSpPr>
             <a:spLocks noGrp="1"/>
           </p:cNvSpPr>
@@ -1888,7 +1659,7 @@
     </p:spTree>
     <p:extLst>
       <p:ext uri="{BB962C8B-B14F-4D97-AF65-F5344CB8AC3E}">
-        <p14:creationId xmlns:p14="http://schemas.microsoft.com/office/powerpoint/2010/main" val="1304780989"/>
+        <p14:creationId xmlns:p14="http://schemas.microsoft.com/office/powerpoint/2010/main" val="446399406"/>
       </p:ext>
     </p:extLst>
   </p:cSld>
@@ -1917,13 +1688,7 @@
       </p:grpSpPr>
       <p:sp>
         <p:nvSpPr>
-          <p:cNvPr id="2" name="Title 1">
-            <a:extLst>
-              <a:ext uri="{FF2B5EF4-FFF2-40B4-BE49-F238E27FC236}">
-                <a16:creationId xmlns:a16="http://schemas.microsoft.com/office/drawing/2014/main" id="{DBE0BE59-667F-4DEC-A6C9-44FADB98CC9B}"/>
-              </a:ext>
-            </a:extLst>
-          </p:cNvPr>
+          <p:cNvPr id="2" name="Title 1"/>
           <p:cNvSpPr>
             <a:spLocks noGrp="1"/>
           </p:cNvSpPr>
@@ -1940,19 +1705,13 @@
               <a:rPr lang="en-US"/>
               <a:t>Click to edit Master title style</a:t>
             </a:r>
-            <a:endParaRPr lang="en-GB"/>
-          </a:p>
-        </p:txBody>
-      </p:sp>
-      <p:sp>
-        <p:nvSpPr>
-          <p:cNvPr id="3" name="Date Placeholder 2">
-            <a:extLst>
-              <a:ext uri="{FF2B5EF4-FFF2-40B4-BE49-F238E27FC236}">
-                <a16:creationId xmlns:a16="http://schemas.microsoft.com/office/drawing/2014/main" id="{019C773F-5F2A-4B9C-A3D4-4E507D656FF4}"/>
-              </a:ext>
-            </a:extLst>
-          </p:cNvPr>
+            <a:endParaRPr lang="en-US" dirty="0"/>
+          </a:p>
+        </p:txBody>
+      </p:sp>
+      <p:sp>
+        <p:nvSpPr>
+          <p:cNvPr id="3" name="Date Placeholder 2"/>
           <p:cNvSpPr>
             <a:spLocks noGrp="1"/>
           </p:cNvSpPr>
@@ -1967,7 +1726,7 @@
           <a:p>
             <a:fld id="{8AE970B3-99CF-4010-BD22-8A76CE724EA0}" type="datetimeFigureOut">
               <a:rPr lang="en-GB" smtClean="0"/>
-              <a:t>04/03/2026</a:t>
+              <a:t>01/04/2026</a:t>
             </a:fld>
             <a:endParaRPr lang="en-GB"/>
           </a:p>
@@ -1975,13 +1734,7 @@
       </p:sp>
       <p:sp>
         <p:nvSpPr>
-          <p:cNvPr id="4" name="Footer Placeholder 3">
-            <a:extLst>
-              <a:ext uri="{FF2B5EF4-FFF2-40B4-BE49-F238E27FC236}">
-                <a16:creationId xmlns:a16="http://schemas.microsoft.com/office/drawing/2014/main" id="{AA242A7C-6DB7-4B8E-A33C-ADA56A1A2C0B}"/>
-              </a:ext>
-            </a:extLst>
-          </p:cNvPr>
+          <p:cNvPr id="4" name="Footer Placeholder 3"/>
           <p:cNvSpPr>
             <a:spLocks noGrp="1"/>
           </p:cNvSpPr>
@@ -2000,13 +1753,7 @@
       </p:sp>
       <p:sp>
         <p:nvSpPr>
-          <p:cNvPr id="5" name="Slide Number Placeholder 4">
-            <a:extLst>
-              <a:ext uri="{FF2B5EF4-FFF2-40B4-BE49-F238E27FC236}">
-                <a16:creationId xmlns:a16="http://schemas.microsoft.com/office/drawing/2014/main" id="{B2DAC407-5B38-4BF2-BBE5-935E3D8C3706}"/>
-              </a:ext>
-            </a:extLst>
-          </p:cNvPr>
+          <p:cNvPr id="5" name="Slide Number Placeholder 4"/>
           <p:cNvSpPr>
             <a:spLocks noGrp="1"/>
           </p:cNvSpPr>
@@ -2030,7 +1777,7 @@
     </p:spTree>
     <p:extLst>
       <p:ext uri="{BB962C8B-B14F-4D97-AF65-F5344CB8AC3E}">
-        <p14:creationId xmlns:p14="http://schemas.microsoft.com/office/powerpoint/2010/main" val="2657680364"/>
+        <p14:creationId xmlns:p14="http://schemas.microsoft.com/office/powerpoint/2010/main" val="2770511581"/>
       </p:ext>
     </p:extLst>
   </p:cSld>
@@ -2059,13 +1806,7 @@
       </p:grpSpPr>
       <p:sp>
         <p:nvSpPr>
-          <p:cNvPr id="2" name="Date Placeholder 1">
-            <a:extLst>
-              <a:ext uri="{FF2B5EF4-FFF2-40B4-BE49-F238E27FC236}">
-                <a16:creationId xmlns:a16="http://schemas.microsoft.com/office/drawing/2014/main" id="{95960B04-7901-4B3E-B750-CCBA3B147752}"/>
-              </a:ext>
-            </a:extLst>
-          </p:cNvPr>
+          <p:cNvPr id="2" name="Date Placeholder 1"/>
           <p:cNvSpPr>
             <a:spLocks noGrp="1"/>
           </p:cNvSpPr>
@@ -2080,7 +1821,7 @@
           <a:p>
             <a:fld id="{8AE970B3-99CF-4010-BD22-8A76CE724EA0}" type="datetimeFigureOut">
               <a:rPr lang="en-GB" smtClean="0"/>
-              <a:t>04/03/2026</a:t>
+              <a:t>01/04/2026</a:t>
             </a:fld>
             <a:endParaRPr lang="en-GB"/>
           </a:p>
@@ -2088,13 +1829,7 @@
       </p:sp>
       <p:sp>
         <p:nvSpPr>
-          <p:cNvPr id="3" name="Footer Placeholder 2">
-            <a:extLst>
-              <a:ext uri="{FF2B5EF4-FFF2-40B4-BE49-F238E27FC236}">
-                <a16:creationId xmlns:a16="http://schemas.microsoft.com/office/drawing/2014/main" id="{3E71EABB-5CB4-48B7-8A13-88DDC09945D6}"/>
-              </a:ext>
-            </a:extLst>
-          </p:cNvPr>
+          <p:cNvPr id="3" name="Footer Placeholder 2"/>
           <p:cNvSpPr>
             <a:spLocks noGrp="1"/>
           </p:cNvSpPr>
@@ -2113,13 +1848,7 @@
       </p:sp>
       <p:sp>
         <p:nvSpPr>
-          <p:cNvPr id="4" name="Slide Number Placeholder 3">
-            <a:extLst>
-              <a:ext uri="{FF2B5EF4-FFF2-40B4-BE49-F238E27FC236}">
-                <a16:creationId xmlns:a16="http://schemas.microsoft.com/office/drawing/2014/main" id="{998E6FC9-EA24-4901-965D-7CE91D0ACEB8}"/>
-              </a:ext>
-            </a:extLst>
-          </p:cNvPr>
+          <p:cNvPr id="4" name="Slide Number Placeholder 3"/>
           <p:cNvSpPr>
             <a:spLocks noGrp="1"/>
           </p:cNvSpPr>
@@ -2143,7 +1872,7 @@
     </p:spTree>
     <p:extLst>
       <p:ext uri="{BB962C8B-B14F-4D97-AF65-F5344CB8AC3E}">
-        <p14:creationId xmlns:p14="http://schemas.microsoft.com/office/powerpoint/2010/main" val="400066612"/>
+        <p14:creationId xmlns:p14="http://schemas.microsoft.com/office/powerpoint/2010/main" val="3325313455"/>
       </p:ext>
     </p:extLst>
   </p:cSld>
@@ -2172,13 +1901,7 @@
       </p:grpSpPr>
       <p:sp>
         <p:nvSpPr>
-          <p:cNvPr id="2" name="Title 1">
-            <a:extLst>
-              <a:ext uri="{FF2B5EF4-FFF2-40B4-BE49-F238E27FC236}">
-                <a16:creationId xmlns:a16="http://schemas.microsoft.com/office/drawing/2014/main" id="{7989FA1A-B3EF-4F68-9FF7-F1CB39864807}"/>
-              </a:ext>
-            </a:extLst>
-          </p:cNvPr>
+          <p:cNvPr id="2" name="Title 1"/>
           <p:cNvSpPr>
             <a:spLocks noGrp="1"/>
           </p:cNvSpPr>
@@ -2188,8 +1911,8 @@
         </p:nvSpPr>
         <p:spPr>
           <a:xfrm>
-            <a:off x="839788" y="457200"/>
-            <a:ext cx="3932237" cy="1600200"/>
+            <a:off x="629841" y="457200"/>
+            <a:ext cx="2949178" cy="1600200"/>
           </a:xfrm>
         </p:spPr>
         <p:txBody>
@@ -2204,19 +1927,13 @@
               <a:rPr lang="en-US"/>
               <a:t>Click to edit Master title style</a:t>
             </a:r>
-            <a:endParaRPr lang="en-GB"/>
-          </a:p>
-        </p:txBody>
-      </p:sp>
-      <p:sp>
-        <p:nvSpPr>
-          <p:cNvPr id="3" name="Content Placeholder 2">
-            <a:extLst>
-              <a:ext uri="{FF2B5EF4-FFF2-40B4-BE49-F238E27FC236}">
-                <a16:creationId xmlns:a16="http://schemas.microsoft.com/office/drawing/2014/main" id="{B9EC4364-70A7-4AEE-A523-BF51D0B03A7B}"/>
-              </a:ext>
-            </a:extLst>
-          </p:cNvPr>
+            <a:endParaRPr lang="en-US" dirty="0"/>
+          </a:p>
+        </p:txBody>
+      </p:sp>
+      <p:sp>
+        <p:nvSpPr>
+          <p:cNvPr id="3" name="Content Placeholder 2"/>
           <p:cNvSpPr>
             <a:spLocks noGrp="1"/>
           </p:cNvSpPr>
@@ -2226,8 +1943,8 @@
         </p:nvSpPr>
         <p:spPr>
           <a:xfrm>
-            <a:off x="5183188" y="987425"/>
-            <a:ext cx="6172200" cy="4873625"/>
+            <a:off x="3887391" y="987426"/>
+            <a:ext cx="4629150" cy="4873625"/>
           </a:xfrm>
         </p:spPr>
         <p:txBody>
@@ -2295,19 +2012,13 @@
               <a:rPr lang="en-US"/>
               <a:t>Fifth level</a:t>
             </a:r>
-            <a:endParaRPr lang="en-GB"/>
-          </a:p>
-        </p:txBody>
-      </p:sp>
-      <p:sp>
-        <p:nvSpPr>
-          <p:cNvPr id="4" name="Text Placeholder 3">
-            <a:extLst>
-              <a:ext uri="{FF2B5EF4-FFF2-40B4-BE49-F238E27FC236}">
-                <a16:creationId xmlns:a16="http://schemas.microsoft.com/office/drawing/2014/main" id="{65D692F2-56AA-4215-8B62-945024B3AA98}"/>
-              </a:ext>
-            </a:extLst>
-          </p:cNvPr>
+            <a:endParaRPr lang="en-US" dirty="0"/>
+          </a:p>
+        </p:txBody>
+      </p:sp>
+      <p:sp>
+        <p:nvSpPr>
+          <p:cNvPr id="4" name="Text Placeholder 3"/>
           <p:cNvSpPr>
             <a:spLocks noGrp="1"/>
           </p:cNvSpPr>
@@ -2317,8 +2028,8 @@
         </p:nvSpPr>
         <p:spPr>
           <a:xfrm>
-            <a:off x="839788" y="2057400"/>
-            <a:ext cx="3932237" cy="3811588"/>
+            <a:off x="629841" y="2057400"/>
+            <a:ext cx="2949178" cy="3811588"/>
           </a:xfrm>
         </p:spPr>
         <p:txBody>
@@ -2372,13 +2083,7 @@
       </p:sp>
       <p:sp>
         <p:nvSpPr>
-          <p:cNvPr id="5" name="Date Placeholder 4">
-            <a:extLst>
-              <a:ext uri="{FF2B5EF4-FFF2-40B4-BE49-F238E27FC236}">
-                <a16:creationId xmlns:a16="http://schemas.microsoft.com/office/drawing/2014/main" id="{C9082BB3-C5B6-4BEE-8431-1CF6B45194D6}"/>
-              </a:ext>
-            </a:extLst>
-          </p:cNvPr>
+          <p:cNvPr id="5" name="Date Placeholder 4"/>
           <p:cNvSpPr>
             <a:spLocks noGrp="1"/>
           </p:cNvSpPr>
@@ -2393,7 +2098,7 @@
           <a:p>
             <a:fld id="{8AE970B3-99CF-4010-BD22-8A76CE724EA0}" type="datetimeFigureOut">
               <a:rPr lang="en-GB" smtClean="0"/>
-              <a:t>04/03/2026</a:t>
+              <a:t>01/04/2026</a:t>
             </a:fld>
             <a:endParaRPr lang="en-GB"/>
           </a:p>
@@ -2401,13 +2106,7 @@
       </p:sp>
       <p:sp>
         <p:nvSpPr>
-          <p:cNvPr id="6" name="Footer Placeholder 5">
-            <a:extLst>
-              <a:ext uri="{FF2B5EF4-FFF2-40B4-BE49-F238E27FC236}">
-                <a16:creationId xmlns:a16="http://schemas.microsoft.com/office/drawing/2014/main" id="{E0A991D4-AE99-4549-943A-9F7633798E93}"/>
-              </a:ext>
-            </a:extLst>
-          </p:cNvPr>
+          <p:cNvPr id="6" name="Footer Placeholder 5"/>
           <p:cNvSpPr>
             <a:spLocks noGrp="1"/>
           </p:cNvSpPr>
@@ -2426,13 +2125,7 @@
       </p:sp>
       <p:sp>
         <p:nvSpPr>
-          <p:cNvPr id="7" name="Slide Number Placeholder 6">
-            <a:extLst>
-              <a:ext uri="{FF2B5EF4-FFF2-40B4-BE49-F238E27FC236}">
-                <a16:creationId xmlns:a16="http://schemas.microsoft.com/office/drawing/2014/main" id="{364893DF-28BE-4869-994B-F14389E3249C}"/>
-              </a:ext>
-            </a:extLst>
-          </p:cNvPr>
+          <p:cNvPr id="7" name="Slide Number Placeholder 6"/>
           <p:cNvSpPr>
             <a:spLocks noGrp="1"/>
           </p:cNvSpPr>
@@ -2456,7 +2149,7 @@
     </p:spTree>
     <p:extLst>
       <p:ext uri="{BB962C8B-B14F-4D97-AF65-F5344CB8AC3E}">
-        <p14:creationId xmlns:p14="http://schemas.microsoft.com/office/powerpoint/2010/main" val="1027882179"/>
+        <p14:creationId xmlns:p14="http://schemas.microsoft.com/office/powerpoint/2010/main" val="1918121714"/>
       </p:ext>
     </p:extLst>
   </p:cSld>
@@ -2485,13 +2178,7 @@
       </p:grpSpPr>
       <p:sp>
         <p:nvSpPr>
-          <p:cNvPr id="2" name="Title 1">
-            <a:extLst>
-              <a:ext uri="{FF2B5EF4-FFF2-40B4-BE49-F238E27FC236}">
-                <a16:creationId xmlns:a16="http://schemas.microsoft.com/office/drawing/2014/main" id="{FE169966-16DC-49EB-ADD3-DDBA85E2C887}"/>
-              </a:ext>
-            </a:extLst>
-          </p:cNvPr>
+          <p:cNvPr id="2" name="Title 1"/>
           <p:cNvSpPr>
             <a:spLocks noGrp="1"/>
           </p:cNvSpPr>
@@ -2501,8 +2188,8 @@
         </p:nvSpPr>
         <p:spPr>
           <a:xfrm>
-            <a:off x="839788" y="457200"/>
-            <a:ext cx="3932237" cy="1600200"/>
+            <a:off x="629841" y="457200"/>
+            <a:ext cx="2949178" cy="1600200"/>
           </a:xfrm>
         </p:spPr>
         <p:txBody>
@@ -2517,21 +2204,15 @@
               <a:rPr lang="en-US"/>
               <a:t>Click to edit Master title style</a:t>
             </a:r>
-            <a:endParaRPr lang="en-GB"/>
-          </a:p>
-        </p:txBody>
-      </p:sp>
-      <p:sp>
-        <p:nvSpPr>
-          <p:cNvPr id="3" name="Picture Placeholder 2">
-            <a:extLst>
-              <a:ext uri="{FF2B5EF4-FFF2-40B4-BE49-F238E27FC236}">
-                <a16:creationId xmlns:a16="http://schemas.microsoft.com/office/drawing/2014/main" id="{8CF00D38-0AB6-4451-A898-1113C52ECABB}"/>
-              </a:ext>
-            </a:extLst>
-          </p:cNvPr>
-          <p:cNvSpPr>
-            <a:spLocks noGrp="1"/>
+            <a:endParaRPr lang="en-US" dirty="0"/>
+          </a:p>
+        </p:txBody>
+      </p:sp>
+      <p:sp>
+        <p:nvSpPr>
+          <p:cNvPr id="3" name="Picture Placeholder 2"/>
+          <p:cNvSpPr>
+            <a:spLocks noGrp="1" noChangeAspect="1"/>
           </p:cNvSpPr>
           <p:nvPr>
             <p:ph type="pic" idx="1"/>
@@ -2539,8 +2220,73 @@
         </p:nvSpPr>
         <p:spPr>
           <a:xfrm>
-            <a:off x="5183188" y="987425"/>
-            <a:ext cx="6172200" cy="4873625"/>
+            <a:off x="3887391" y="987426"/>
+            <a:ext cx="4629150" cy="4873625"/>
+          </a:xfrm>
+        </p:spPr>
+        <p:txBody>
+          <a:bodyPr anchor="t"/>
+          <a:lstStyle>
+            <a:lvl1pPr marL="0" indent="0">
+              <a:buNone/>
+              <a:defRPr sz="3200"/>
+            </a:lvl1pPr>
+            <a:lvl2pPr marL="457200" indent="0">
+              <a:buNone/>
+              <a:defRPr sz="2800"/>
+            </a:lvl2pPr>
+            <a:lvl3pPr marL="914400" indent="0">
+              <a:buNone/>
+              <a:defRPr sz="2400"/>
+            </a:lvl3pPr>
+            <a:lvl4pPr marL="1371600" indent="0">
+              <a:buNone/>
+              <a:defRPr sz="2000"/>
+            </a:lvl4pPr>
+            <a:lvl5pPr marL="1828800" indent="0">
+              <a:buNone/>
+              <a:defRPr sz="2000"/>
+            </a:lvl5pPr>
+            <a:lvl6pPr marL="2286000" indent="0">
+              <a:buNone/>
+              <a:defRPr sz="2000"/>
+            </a:lvl6pPr>
+            <a:lvl7pPr marL="2743200" indent="0">
+              <a:buNone/>
+              <a:defRPr sz="2000"/>
+            </a:lvl7pPr>
+            <a:lvl8pPr marL="3200400" indent="0">
+              <a:buNone/>
+              <a:defRPr sz="2000"/>
+            </a:lvl8pPr>
+            <a:lvl9pPr marL="3657600" indent="0">
+              <a:buNone/>
+              <a:defRPr sz="2000"/>
+            </a:lvl9pPr>
+          </a:lstStyle>
+          <a:p>
+            <a:r>
+              <a:rPr lang="en-US"/>
+              <a:t>Click icon to add picture</a:t>
+            </a:r>
+            <a:endParaRPr lang="en-US" dirty="0"/>
+          </a:p>
+        </p:txBody>
+      </p:sp>
+      <p:sp>
+        <p:nvSpPr>
+          <p:cNvPr id="4" name="Text Placeholder 3"/>
+          <p:cNvSpPr>
+            <a:spLocks noGrp="1"/>
+          </p:cNvSpPr>
+          <p:nvPr>
+            <p:ph type="body" sz="half" idx="2"/>
+          </p:nvPr>
+        </p:nvSpPr>
+        <p:spPr>
+          <a:xfrm>
+            <a:off x="629841" y="2057400"/>
+            <a:ext cx="2949178" cy="3811588"/>
           </a:xfrm>
         </p:spPr>
         <p:txBody>
@@ -2548,73 +2294,6 @@
           <a:lstStyle>
             <a:lvl1pPr marL="0" indent="0">
               <a:buNone/>
-              <a:defRPr sz="3200"/>
-            </a:lvl1pPr>
-            <a:lvl2pPr marL="457200" indent="0">
-              <a:buNone/>
-              <a:defRPr sz="2800"/>
-            </a:lvl2pPr>
-            <a:lvl3pPr marL="914400" indent="0">
-              <a:buNone/>
-              <a:defRPr sz="2400"/>
-            </a:lvl3pPr>
-            <a:lvl4pPr marL="1371600" indent="0">
-              <a:buNone/>
-              <a:defRPr sz="2000"/>
-            </a:lvl4pPr>
-            <a:lvl5pPr marL="1828800" indent="0">
-              <a:buNone/>
-              <a:defRPr sz="2000"/>
-            </a:lvl5pPr>
-            <a:lvl6pPr marL="2286000" indent="0">
-              <a:buNone/>
-              <a:defRPr sz="2000"/>
-            </a:lvl6pPr>
-            <a:lvl7pPr marL="2743200" indent="0">
-              <a:buNone/>
-              <a:defRPr sz="2000"/>
-            </a:lvl7pPr>
-            <a:lvl8pPr marL="3200400" indent="0">
-              <a:buNone/>
-              <a:defRPr sz="2000"/>
-            </a:lvl8pPr>
-            <a:lvl9pPr marL="3657600" indent="0">
-              <a:buNone/>
-              <a:defRPr sz="2000"/>
-            </a:lvl9pPr>
-          </a:lstStyle>
-          <a:p>
-            <a:endParaRPr lang="en-GB"/>
-          </a:p>
-        </p:txBody>
-      </p:sp>
-      <p:sp>
-        <p:nvSpPr>
-          <p:cNvPr id="4" name="Text Placeholder 3">
-            <a:extLst>
-              <a:ext uri="{FF2B5EF4-FFF2-40B4-BE49-F238E27FC236}">
-                <a16:creationId xmlns:a16="http://schemas.microsoft.com/office/drawing/2014/main" id="{45FA02A7-D61B-4140-8F6C-8653098A3E78}"/>
-              </a:ext>
-            </a:extLst>
-          </p:cNvPr>
-          <p:cNvSpPr>
-            <a:spLocks noGrp="1"/>
-          </p:cNvSpPr>
-          <p:nvPr>
-            <p:ph type="body" sz="half" idx="2"/>
-          </p:nvPr>
-        </p:nvSpPr>
-        <p:spPr>
-          <a:xfrm>
-            <a:off x="839788" y="2057400"/>
-            <a:ext cx="3932237" cy="3811588"/>
-          </a:xfrm>
-        </p:spPr>
-        <p:txBody>
-          <a:bodyPr/>
-          <a:lstStyle>
-            <a:lvl1pPr marL="0" indent="0">
-              <a:buNone/>
               <a:defRPr sz="1600"/>
             </a:lvl1pPr>
             <a:lvl2pPr marL="457200" indent="0">
@@ -2661,13 +2340,7 @@
       </p:sp>
       <p:sp>
         <p:nvSpPr>
-          <p:cNvPr id="5" name="Date Placeholder 4">
-            <a:extLst>
-              <a:ext uri="{FF2B5EF4-FFF2-40B4-BE49-F238E27FC236}">
-                <a16:creationId xmlns:a16="http://schemas.microsoft.com/office/drawing/2014/main" id="{E7ACCE2A-325E-4186-84DE-12B1800462A3}"/>
-              </a:ext>
-            </a:extLst>
-          </p:cNvPr>
+          <p:cNvPr id="5" name="Date Placeholder 4"/>
           <p:cNvSpPr>
             <a:spLocks noGrp="1"/>
           </p:cNvSpPr>
@@ -2682,7 +2355,7 @@
           <a:p>
             <a:fld id="{8AE970B3-99CF-4010-BD22-8A76CE724EA0}" type="datetimeFigureOut">
               <a:rPr lang="en-GB" smtClean="0"/>
-              <a:t>04/03/2026</a:t>
+              <a:t>01/04/2026</a:t>
             </a:fld>
             <a:endParaRPr lang="en-GB"/>
           </a:p>
@@ -2690,13 +2363,7 @@
       </p:sp>
       <p:sp>
         <p:nvSpPr>
-          <p:cNvPr id="6" name="Footer Placeholder 5">
-            <a:extLst>
-              <a:ext uri="{FF2B5EF4-FFF2-40B4-BE49-F238E27FC236}">
-                <a16:creationId xmlns:a16="http://schemas.microsoft.com/office/drawing/2014/main" id="{07D998AC-EAA4-40F3-8165-9121EA5B4B2E}"/>
-              </a:ext>
-            </a:extLst>
-          </p:cNvPr>
+          <p:cNvPr id="6" name="Footer Placeholder 5"/>
           <p:cNvSpPr>
             <a:spLocks noGrp="1"/>
           </p:cNvSpPr>
@@ -2715,13 +2382,7 @@
       </p:sp>
       <p:sp>
         <p:nvSpPr>
-          <p:cNvPr id="7" name="Slide Number Placeholder 6">
-            <a:extLst>
-              <a:ext uri="{FF2B5EF4-FFF2-40B4-BE49-F238E27FC236}">
-                <a16:creationId xmlns:a16="http://schemas.microsoft.com/office/drawing/2014/main" id="{52D5EBDA-5EC4-46F4-BFF0-D59FDC6411DC}"/>
-              </a:ext>
-            </a:extLst>
-          </p:cNvPr>
+          <p:cNvPr id="7" name="Slide Number Placeholder 6"/>
           <p:cNvSpPr>
             <a:spLocks noGrp="1"/>
           </p:cNvSpPr>
@@ -2745,7 +2406,7 @@
     </p:spTree>
     <p:extLst>
       <p:ext uri="{BB962C8B-B14F-4D97-AF65-F5344CB8AC3E}">
-        <p14:creationId xmlns:p14="http://schemas.microsoft.com/office/powerpoint/2010/main" val="1937442488"/>
+        <p14:creationId xmlns:p14="http://schemas.microsoft.com/office/powerpoint/2010/main" val="731711384"/>
       </p:ext>
     </p:extLst>
   </p:cSld>
@@ -2759,16 +2420,9 @@
 <p:sldMaster xmlns:a="http://schemas.openxmlformats.org/drawingml/2006/main" xmlns:r="http://schemas.openxmlformats.org/officeDocument/2006/relationships" xmlns:p="http://schemas.openxmlformats.org/presentationml/2006/main">
   <p:cSld>
     <p:bg>
-      <p:bgPr>
-        <a:blipFill dpi="0" rotWithShape="1">
-          <a:blip r:embed="rId13">
-            <a:lum/>
-          </a:blip>
-          <a:srcRect/>
-          <a:tile tx="0" ty="0" sx="100000" sy="100000" flip="y" algn="tl"/>
-        </a:blipFill>
-        <a:effectLst/>
-      </p:bgPr>
+      <p:bgRef idx="1001">
+        <a:schemeClr val="bg1"/>
+      </p:bgRef>
     </p:bg>
     <p:spTree>
       <p:nvGrpSpPr>
@@ -2786,13 +2440,7 @@
       </p:grpSpPr>
       <p:sp>
         <p:nvSpPr>
-          <p:cNvPr id="2" name="Title Placeholder 1">
-            <a:extLst>
-              <a:ext uri="{FF2B5EF4-FFF2-40B4-BE49-F238E27FC236}">
-                <a16:creationId xmlns:a16="http://schemas.microsoft.com/office/drawing/2014/main" id="{F7C6E230-B664-4F92-B6D4-925D9D4DB083}"/>
-              </a:ext>
-            </a:extLst>
-          </p:cNvPr>
+          <p:cNvPr id="2" name="Title Placeholder 1"/>
           <p:cNvSpPr>
             <a:spLocks noGrp="1"/>
           </p:cNvSpPr>
@@ -2802,8 +2450,8 @@
         </p:nvSpPr>
         <p:spPr>
           <a:xfrm>
-            <a:off x="838200" y="365125"/>
-            <a:ext cx="10515600" cy="1325563"/>
+            <a:off x="628650" y="365126"/>
+            <a:ext cx="7886700" cy="1325563"/>
           </a:xfrm>
           <a:prstGeom prst="rect">
             <a:avLst/>
@@ -2819,19 +2467,13 @@
               <a:rPr lang="en-US"/>
               <a:t>Click to edit Master title style</a:t>
             </a:r>
-            <a:endParaRPr lang="en-GB"/>
-          </a:p>
-        </p:txBody>
-      </p:sp>
-      <p:sp>
-        <p:nvSpPr>
-          <p:cNvPr id="3" name="Text Placeholder 2">
-            <a:extLst>
-              <a:ext uri="{FF2B5EF4-FFF2-40B4-BE49-F238E27FC236}">
-                <a16:creationId xmlns:a16="http://schemas.microsoft.com/office/drawing/2014/main" id="{DF928902-9CE7-4025-AD77-1099BC9F4EA2}"/>
-              </a:ext>
-            </a:extLst>
-          </p:cNvPr>
+            <a:endParaRPr lang="en-US" dirty="0"/>
+          </a:p>
+        </p:txBody>
+      </p:sp>
+      <p:sp>
+        <p:nvSpPr>
+          <p:cNvPr id="3" name="Text Placeholder 2"/>
           <p:cNvSpPr>
             <a:spLocks noGrp="1"/>
           </p:cNvSpPr>
@@ -2841,8 +2483,8 @@
         </p:nvSpPr>
         <p:spPr>
           <a:xfrm>
-            <a:off x="838200" y="1825625"/>
-            <a:ext cx="10515600" cy="4351338"/>
+            <a:off x="628650" y="1825625"/>
+            <a:ext cx="7886700" cy="4351338"/>
           </a:xfrm>
           <a:prstGeom prst="rect">
             <a:avLst/>
@@ -2887,19 +2529,13 @@
               <a:rPr lang="en-US"/>
               <a:t>Fifth level</a:t>
             </a:r>
-            <a:endParaRPr lang="en-GB"/>
-          </a:p>
-        </p:txBody>
-      </p:sp>
-      <p:sp>
-        <p:nvSpPr>
-          <p:cNvPr id="4" name="Date Placeholder 3">
-            <a:extLst>
-              <a:ext uri="{FF2B5EF4-FFF2-40B4-BE49-F238E27FC236}">
-                <a16:creationId xmlns:a16="http://schemas.microsoft.com/office/drawing/2014/main" id="{DC3327A5-95FD-496F-9324-CE3EFF67C72C}"/>
-              </a:ext>
-            </a:extLst>
-          </p:cNvPr>
+            <a:endParaRPr lang="en-US" dirty="0"/>
+          </a:p>
+        </p:txBody>
+      </p:sp>
+      <p:sp>
+        <p:nvSpPr>
+          <p:cNvPr id="4" name="Date Placeholder 3"/>
           <p:cNvSpPr>
             <a:spLocks noGrp="1"/>
           </p:cNvSpPr>
@@ -2909,8 +2545,8 @@
         </p:nvSpPr>
         <p:spPr>
           <a:xfrm>
-            <a:off x="838200" y="6356350"/>
-            <a:ext cx="2743200" cy="365125"/>
+            <a:off x="628650" y="6356351"/>
+            <a:ext cx="2057400" cy="365125"/>
           </a:xfrm>
           <a:prstGeom prst="rect">
             <a:avLst/>
@@ -2932,7 +2568,7 @@
           <a:p>
             <a:fld id="{8AE970B3-99CF-4010-BD22-8A76CE724EA0}" type="datetimeFigureOut">
               <a:rPr lang="en-GB" smtClean="0"/>
-              <a:t>04/03/2026</a:t>
+              <a:t>01/04/2026</a:t>
             </a:fld>
             <a:endParaRPr lang="en-GB"/>
           </a:p>
@@ -2940,13 +2576,7 @@
       </p:sp>
       <p:sp>
         <p:nvSpPr>
-          <p:cNvPr id="5" name="Footer Placeholder 4">
-            <a:extLst>
-              <a:ext uri="{FF2B5EF4-FFF2-40B4-BE49-F238E27FC236}">
-                <a16:creationId xmlns:a16="http://schemas.microsoft.com/office/drawing/2014/main" id="{4C2BE613-2F30-4B44-842E-651DE7E585CF}"/>
-              </a:ext>
-            </a:extLst>
-          </p:cNvPr>
+          <p:cNvPr id="5" name="Footer Placeholder 4"/>
           <p:cNvSpPr>
             <a:spLocks noGrp="1"/>
           </p:cNvSpPr>
@@ -2956,8 +2586,8 @@
         </p:nvSpPr>
         <p:spPr>
           <a:xfrm>
-            <a:off x="4038600" y="6356350"/>
-            <a:ext cx="4114800" cy="365125"/>
+            <a:off x="3028950" y="6356351"/>
+            <a:ext cx="3086100" cy="365125"/>
           </a:xfrm>
           <a:prstGeom prst="rect">
             <a:avLst/>
@@ -2983,13 +2613,7 @@
       </p:sp>
       <p:sp>
         <p:nvSpPr>
-          <p:cNvPr id="6" name="Slide Number Placeholder 5">
-            <a:extLst>
-              <a:ext uri="{FF2B5EF4-FFF2-40B4-BE49-F238E27FC236}">
-                <a16:creationId xmlns:a16="http://schemas.microsoft.com/office/drawing/2014/main" id="{A8E1FEF2-1F7C-4943-99D7-907B8C565236}"/>
-              </a:ext>
-            </a:extLst>
-          </p:cNvPr>
+          <p:cNvPr id="6" name="Slide Number Placeholder 5"/>
           <p:cNvSpPr>
             <a:spLocks noGrp="1"/>
           </p:cNvSpPr>
@@ -2999,8 +2623,8 @@
         </p:nvSpPr>
         <p:spPr>
           <a:xfrm>
-            <a:off x="8610600" y="6356350"/>
-            <a:ext cx="2743200" cy="365125"/>
+            <a:off x="6457950" y="6356351"/>
+            <a:ext cx="2057400" cy="365125"/>
           </a:xfrm>
           <a:prstGeom prst="rect">
             <a:avLst/>
@@ -3031,23 +2655,23 @@
     </p:spTree>
     <p:extLst>
       <p:ext uri="{BB962C8B-B14F-4D97-AF65-F5344CB8AC3E}">
-        <p14:creationId xmlns:p14="http://schemas.microsoft.com/office/powerpoint/2010/main" val="421041850"/>
+        <p14:creationId xmlns:p14="http://schemas.microsoft.com/office/powerpoint/2010/main" val="743736299"/>
       </p:ext>
     </p:extLst>
   </p:cSld>
   <p:clrMap bg1="lt1" tx1="dk1" bg2="lt2" tx2="dk2" accent1="accent1" accent2="accent2" accent3="accent3" accent4="accent4" accent5="accent5" accent6="accent6" hlink="hlink" folHlink="folHlink"/>
   <p:sldLayoutIdLst>
-    <p:sldLayoutId id="2147483649" r:id="rId1"/>
-    <p:sldLayoutId id="2147483650" r:id="rId2"/>
-    <p:sldLayoutId id="2147483651" r:id="rId3"/>
-    <p:sldLayoutId id="2147483652" r:id="rId4"/>
-    <p:sldLayoutId id="2147483653" r:id="rId5"/>
-    <p:sldLayoutId id="2147483654" r:id="rId6"/>
-    <p:sldLayoutId id="2147483655" r:id="rId7"/>
-    <p:sldLayoutId id="2147483656" r:id="rId8"/>
-    <p:sldLayoutId id="2147483657" r:id="rId9"/>
-    <p:sldLayoutId id="2147483658" r:id="rId10"/>
-    <p:sldLayoutId id="2147483659" r:id="rId11"/>
+    <p:sldLayoutId id="2147483661" r:id="rId1"/>
+    <p:sldLayoutId id="2147483662" r:id="rId2"/>
+    <p:sldLayoutId id="2147483663" r:id="rId3"/>
+    <p:sldLayoutId id="2147483664" r:id="rId4"/>
+    <p:sldLayoutId id="2147483665" r:id="rId5"/>
+    <p:sldLayoutId id="2147483666" r:id="rId6"/>
+    <p:sldLayoutId id="2147483667" r:id="rId7"/>
+    <p:sldLayoutId id="2147483668" r:id="rId8"/>
+    <p:sldLayoutId id="2147483669" r:id="rId9"/>
+    <p:sldLayoutId id="2147483670" r:id="rId10"/>
+    <p:sldLayoutId id="2147483671" r:id="rId11"/>
   </p:sldLayoutIdLst>
   <p:txStyles>
     <p:titleStyle>
@@ -3335,18 +2959,6 @@
 <file path=ppt/slides/slide1.xml><?xml version="1.0" encoding="utf-8"?>
 <p:sld xmlns:a="http://schemas.openxmlformats.org/drawingml/2006/main" xmlns:r="http://schemas.openxmlformats.org/officeDocument/2006/relationships" xmlns:p="http://schemas.openxmlformats.org/presentationml/2006/main">
   <p:cSld>
-    <p:bg>
-      <p:bgPr>
-        <a:blipFill dpi="0" rotWithShape="1">
-          <a:blip r:embed="rId2">
-            <a:lum/>
-          </a:blip>
-          <a:srcRect/>
-          <a:tile tx="0" ty="0" sx="100000" sy="100000" flip="x" algn="tl"/>
-        </a:blipFill>
-        <a:effectLst/>
-      </p:bgPr>
-    </p:bg>
     <p:spTree>
       <p:nvGrpSpPr>
         <p:cNvPr id="1" name=""/>
@@ -3363,10 +2975,10 @@
       </p:grpSpPr>
       <p:sp>
         <p:nvSpPr>
-          <p:cNvPr id="10" name="Oval 9">
+          <p:cNvPr id="6" name="Oval 5">
             <a:extLst>
               <a:ext uri="{FF2B5EF4-FFF2-40B4-BE49-F238E27FC236}">
-                <a16:creationId xmlns:a16="http://schemas.microsoft.com/office/drawing/2014/main" id="{9856DEF0-5CF7-4333-BCA9-D4EE1CFF5166}"/>
+                <a16:creationId xmlns:a16="http://schemas.microsoft.com/office/drawing/2014/main" id="{2643A07D-5A86-BB99-BD9F-C8A4928688CE}"/>
               </a:ext>
             </a:extLst>
           </p:cNvPr>
@@ -3375,26 +2987,17 @@
         </p:nvSpPr>
         <p:spPr>
           <a:xfrm>
-            <a:off x="2475825" y="853725"/>
-            <a:ext cx="1119673" cy="1119673"/>
+            <a:off x="3855026" y="313458"/>
+            <a:ext cx="1433946" cy="1433946"/>
           </a:xfrm>
           <a:prstGeom prst="ellipse">
             <a:avLst/>
           </a:prstGeom>
-          <a:solidFill>
-            <a:schemeClr val="accent4">
-              <a:lumMod val="20000"/>
-              <a:lumOff val="80000"/>
-            </a:schemeClr>
-          </a:solidFill>
-          <a:ln>
-            <a:noFill/>
-          </a:ln>
         </p:spPr>
         <p:style>
           <a:lnRef idx="2">
             <a:schemeClr val="accent1">
-              <a:shade val="50000"/>
+              <a:shade val="15000"/>
             </a:schemeClr>
           </a:lnRef>
           <a:fillRef idx="1">
@@ -3418,10 +3021,10 @@
       </p:sp>
       <p:sp>
         <p:nvSpPr>
-          <p:cNvPr id="11" name="Oval 10">
+          <p:cNvPr id="14" name="Oval 13">
             <a:extLst>
               <a:ext uri="{FF2B5EF4-FFF2-40B4-BE49-F238E27FC236}">
-                <a16:creationId xmlns:a16="http://schemas.microsoft.com/office/drawing/2014/main" id="{441B587A-31D9-4575-97D6-04106C1308B2}"/>
+                <a16:creationId xmlns:a16="http://schemas.microsoft.com/office/drawing/2014/main" id="{FFC783C0-A974-6459-C045-B298A206D352}"/>
               </a:ext>
             </a:extLst>
           </p:cNvPr>
@@ -3430,26 +3033,17 @@
         </p:nvSpPr>
         <p:spPr>
           <a:xfrm>
-            <a:off x="3663387" y="4711940"/>
-            <a:ext cx="1119673" cy="1119673"/>
+            <a:off x="5605894" y="1030431"/>
+            <a:ext cx="1433946" cy="1433946"/>
           </a:xfrm>
           <a:prstGeom prst="ellipse">
             <a:avLst/>
           </a:prstGeom>
-          <a:solidFill>
-            <a:schemeClr val="accent4">
-              <a:lumMod val="20000"/>
-              <a:lumOff val="80000"/>
-            </a:schemeClr>
-          </a:solidFill>
-          <a:ln>
-            <a:noFill/>
-          </a:ln>
         </p:spPr>
         <p:style>
           <a:lnRef idx="2">
             <a:schemeClr val="accent1">
-              <a:shade val="50000"/>
+              <a:shade val="15000"/>
             </a:schemeClr>
           </a:lnRef>
           <a:fillRef idx="1">
@@ -3473,10 +3067,10 @@
       </p:sp>
       <p:sp>
         <p:nvSpPr>
-          <p:cNvPr id="12" name="Oval 11">
+          <p:cNvPr id="15" name="Oval 14">
             <a:extLst>
               <a:ext uri="{FF2B5EF4-FFF2-40B4-BE49-F238E27FC236}">
-                <a16:creationId xmlns:a16="http://schemas.microsoft.com/office/drawing/2014/main" id="{3E1FE242-703F-4A25-9DB9-2EB314029AE7}"/>
+                <a16:creationId xmlns:a16="http://schemas.microsoft.com/office/drawing/2014/main" id="{CFB6DC38-6407-1ADC-0131-32ED14C08696}"/>
               </a:ext>
             </a:extLst>
           </p:cNvPr>
@@ -3485,26 +3079,17 @@
         </p:nvSpPr>
         <p:spPr>
           <a:xfrm>
-            <a:off x="2463581" y="4152104"/>
-            <a:ext cx="1119673" cy="1119673"/>
+            <a:off x="6322867" y="2712026"/>
+            <a:ext cx="1433946" cy="1433946"/>
           </a:xfrm>
           <a:prstGeom prst="ellipse">
             <a:avLst/>
           </a:prstGeom>
-          <a:solidFill>
-            <a:schemeClr val="accent4">
-              <a:lumMod val="20000"/>
-              <a:lumOff val="80000"/>
-            </a:schemeClr>
-          </a:solidFill>
-          <a:ln>
-            <a:noFill/>
-          </a:ln>
         </p:spPr>
         <p:style>
           <a:lnRef idx="2">
             <a:schemeClr val="accent1">
-              <a:shade val="50000"/>
+              <a:shade val="15000"/>
             </a:schemeClr>
           </a:lnRef>
           <a:fillRef idx="1">
@@ -3528,10 +3113,10 @@
       </p:sp>
       <p:sp>
         <p:nvSpPr>
-          <p:cNvPr id="14" name="Oval 13">
+          <p:cNvPr id="16" name="Oval 15">
             <a:extLst>
               <a:ext uri="{FF2B5EF4-FFF2-40B4-BE49-F238E27FC236}">
-                <a16:creationId xmlns:a16="http://schemas.microsoft.com/office/drawing/2014/main" id="{8DD90530-209D-4AA1-8AC9-C35F8EA6CEDF}"/>
+                <a16:creationId xmlns:a16="http://schemas.microsoft.com/office/drawing/2014/main" id="{7239F3A0-C32E-836B-E0A5-8DCBCC93CC94}"/>
               </a:ext>
             </a:extLst>
           </p:cNvPr>
@@ -3540,26 +3125,17 @@
         </p:nvSpPr>
         <p:spPr>
           <a:xfrm>
-            <a:off x="1632457" y="1912749"/>
-            <a:ext cx="1119673" cy="1119673"/>
+            <a:off x="5605894" y="4393621"/>
+            <a:ext cx="1433946" cy="1433946"/>
           </a:xfrm>
           <a:prstGeom prst="ellipse">
             <a:avLst/>
           </a:prstGeom>
-          <a:solidFill>
-            <a:schemeClr val="accent4">
-              <a:lumMod val="20000"/>
-              <a:lumOff val="80000"/>
-            </a:schemeClr>
-          </a:solidFill>
-          <a:ln>
-            <a:noFill/>
-          </a:ln>
         </p:spPr>
         <p:style>
           <a:lnRef idx="2">
             <a:schemeClr val="accent1">
-              <a:shade val="50000"/>
+              <a:shade val="15000"/>
             </a:schemeClr>
           </a:lnRef>
           <a:fillRef idx="1">
@@ -3583,10 +3159,10 @@
       </p:sp>
       <p:sp>
         <p:nvSpPr>
-          <p:cNvPr id="15" name="Oval 14">
+          <p:cNvPr id="17" name="Oval 16">
             <a:extLst>
               <a:ext uri="{FF2B5EF4-FFF2-40B4-BE49-F238E27FC236}">
-                <a16:creationId xmlns:a16="http://schemas.microsoft.com/office/drawing/2014/main" id="{D7AD3288-7ED6-4C32-8CF4-FF0AE4DFFDA2}"/>
+                <a16:creationId xmlns:a16="http://schemas.microsoft.com/office/drawing/2014/main" id="{5D55022B-64D8-65D4-C1B5-E7473710079A}"/>
               </a:ext>
             </a:extLst>
           </p:cNvPr>
@@ -3595,26 +3171,17 @@
         </p:nvSpPr>
         <p:spPr>
           <a:xfrm>
-            <a:off x="3660375" y="347544"/>
-            <a:ext cx="1119673" cy="1119673"/>
+            <a:off x="3855026" y="5110595"/>
+            <a:ext cx="1433946" cy="1433946"/>
           </a:xfrm>
           <a:prstGeom prst="ellipse">
             <a:avLst/>
           </a:prstGeom>
-          <a:solidFill>
-            <a:schemeClr val="accent4">
-              <a:lumMod val="20000"/>
-              <a:lumOff val="80000"/>
-            </a:schemeClr>
-          </a:solidFill>
-          <a:ln>
-            <a:noFill/>
-          </a:ln>
         </p:spPr>
         <p:style>
           <a:lnRef idx="2">
             <a:schemeClr val="accent1">
-              <a:shade val="50000"/>
+              <a:shade val="15000"/>
             </a:schemeClr>
           </a:lnRef>
           <a:fillRef idx="1">
@@ -3638,10 +3205,10 @@
       </p:sp>
       <p:sp>
         <p:nvSpPr>
-          <p:cNvPr id="19" name="Oval 18">
+          <p:cNvPr id="18" name="Oval 17">
             <a:extLst>
               <a:ext uri="{FF2B5EF4-FFF2-40B4-BE49-F238E27FC236}">
-                <a16:creationId xmlns:a16="http://schemas.microsoft.com/office/drawing/2014/main" id="{7992F40F-A1AB-4935-8633-D5D2B4AE3668}"/>
+                <a16:creationId xmlns:a16="http://schemas.microsoft.com/office/drawing/2014/main" id="{9A460C49-2524-F521-B005-1CD4DCF412B8}"/>
               </a:ext>
             </a:extLst>
           </p:cNvPr>
@@ -3650,26 +3217,17 @@
         </p:nvSpPr>
         <p:spPr>
           <a:xfrm>
-            <a:off x="1647147" y="3205063"/>
-            <a:ext cx="1119673" cy="1119673"/>
+            <a:off x="2104158" y="1030431"/>
+            <a:ext cx="1433946" cy="1433946"/>
           </a:xfrm>
           <a:prstGeom prst="ellipse">
             <a:avLst/>
           </a:prstGeom>
-          <a:solidFill>
-            <a:schemeClr val="accent4">
-              <a:lumMod val="20000"/>
-              <a:lumOff val="80000"/>
-            </a:schemeClr>
-          </a:solidFill>
-          <a:ln>
-            <a:noFill/>
-          </a:ln>
         </p:spPr>
         <p:style>
           <a:lnRef idx="2">
             <a:schemeClr val="accent1">
-              <a:shade val="50000"/>
+              <a:shade val="15000"/>
             </a:schemeClr>
           </a:lnRef>
           <a:fillRef idx="1">
@@ -3693,10 +3251,10 @@
       </p:sp>
       <p:sp>
         <p:nvSpPr>
-          <p:cNvPr id="20" name="Oval 19">
+          <p:cNvPr id="19" name="Oval 18">
             <a:extLst>
               <a:ext uri="{FF2B5EF4-FFF2-40B4-BE49-F238E27FC236}">
-                <a16:creationId xmlns:a16="http://schemas.microsoft.com/office/drawing/2014/main" id="{6C316A31-19D5-477E-B0FE-511E78C1E969}"/>
+                <a16:creationId xmlns:a16="http://schemas.microsoft.com/office/drawing/2014/main" id="{4060445E-7EEF-84B1-E719-71F563F0300C}"/>
               </a:ext>
             </a:extLst>
           </p:cNvPr>
@@ -3705,26 +3263,17 @@
         </p:nvSpPr>
         <p:spPr>
           <a:xfrm>
-            <a:off x="4883668" y="4110114"/>
-            <a:ext cx="1119673" cy="1119673"/>
+            <a:off x="1387185" y="2712026"/>
+            <a:ext cx="1433946" cy="1433946"/>
           </a:xfrm>
           <a:prstGeom prst="ellipse">
             <a:avLst/>
           </a:prstGeom>
-          <a:solidFill>
-            <a:schemeClr val="accent4">
-              <a:lumMod val="20000"/>
-              <a:lumOff val="80000"/>
-            </a:schemeClr>
-          </a:solidFill>
-          <a:ln>
-            <a:noFill/>
-          </a:ln>
         </p:spPr>
         <p:style>
           <a:lnRef idx="2">
             <a:schemeClr val="accent1">
-              <a:shade val="50000"/>
+              <a:shade val="15000"/>
             </a:schemeClr>
           </a:lnRef>
           <a:fillRef idx="1">
@@ -3748,10 +3297,10 @@
       </p:sp>
       <p:sp>
         <p:nvSpPr>
-          <p:cNvPr id="21" name="Oval 20">
+          <p:cNvPr id="20" name="Oval 19">
             <a:extLst>
               <a:ext uri="{FF2B5EF4-FFF2-40B4-BE49-F238E27FC236}">
-                <a16:creationId xmlns:a16="http://schemas.microsoft.com/office/drawing/2014/main" id="{E042D2A7-A857-4A35-95AA-98AE42B1D2F7}"/>
+                <a16:creationId xmlns:a16="http://schemas.microsoft.com/office/drawing/2014/main" id="{511489E6-629F-4A8B-3465-C001CA9D1009}"/>
               </a:ext>
             </a:extLst>
           </p:cNvPr>
@@ -3760,26 +3309,17 @@
         </p:nvSpPr>
         <p:spPr>
           <a:xfrm>
-            <a:off x="5862570" y="3205064"/>
-            <a:ext cx="1119673" cy="1119673"/>
+            <a:off x="2104157" y="4393621"/>
+            <a:ext cx="1433946" cy="1433946"/>
           </a:xfrm>
           <a:prstGeom prst="ellipse">
             <a:avLst/>
           </a:prstGeom>
-          <a:solidFill>
-            <a:schemeClr val="accent4">
-              <a:lumMod val="20000"/>
-              <a:lumOff val="80000"/>
-            </a:schemeClr>
-          </a:solidFill>
-          <a:ln>
-            <a:noFill/>
-          </a:ln>
         </p:spPr>
         <p:style>
           <a:lnRef idx="2">
             <a:schemeClr val="accent1">
-              <a:shade val="50000"/>
+              <a:shade val="15000"/>
             </a:schemeClr>
           </a:lnRef>
           <a:fillRef idx="1">
@@ -3803,10 +3343,10 @@
       </p:sp>
       <p:sp>
         <p:nvSpPr>
-          <p:cNvPr id="22" name="Oval 21">
+          <p:cNvPr id="13" name="Star: 8 Points 12">
             <a:extLst>
               <a:ext uri="{FF2B5EF4-FFF2-40B4-BE49-F238E27FC236}">
-                <a16:creationId xmlns:a16="http://schemas.microsoft.com/office/drawing/2014/main" id="{3B7D5ADD-21FF-49BF-AF81-0388C6D38EEC}"/>
+                <a16:creationId xmlns:a16="http://schemas.microsoft.com/office/drawing/2014/main" id="{BAB9D564-A872-BD46-357A-3FF4A71E7C43}"/>
               </a:ext>
             </a:extLst>
           </p:cNvPr>
@@ -3815,26 +3355,17 @@
         </p:nvSpPr>
         <p:spPr>
           <a:xfrm>
-            <a:off x="5848918" y="1978080"/>
-            <a:ext cx="1119673" cy="1119673"/>
+            <a:off x="2104158" y="1030431"/>
+            <a:ext cx="4935683" cy="4797137"/>
           </a:xfrm>
-          <a:prstGeom prst="ellipse">
+          <a:prstGeom prst="star8">
             <a:avLst/>
           </a:prstGeom>
-          <a:solidFill>
-            <a:schemeClr val="accent4">
-              <a:lumMod val="20000"/>
-              <a:lumOff val="80000"/>
-            </a:schemeClr>
-          </a:solidFill>
-          <a:ln>
-            <a:noFill/>
-          </a:ln>
         </p:spPr>
         <p:style>
           <a:lnRef idx="2">
             <a:schemeClr val="accent1">
-              <a:shade val="50000"/>
+              <a:shade val="15000"/>
             </a:schemeClr>
           </a:lnRef>
           <a:fillRef idx="1">
@@ -3856,466 +3387,48 @@
           </a:p>
         </p:txBody>
       </p:sp>
-      <p:sp>
-        <p:nvSpPr>
-          <p:cNvPr id="23" name="Oval 22">
+    </p:spTree>
+    <p:extLst>
+      <p:ext uri="{BB962C8B-B14F-4D97-AF65-F5344CB8AC3E}">
+        <p14:creationId xmlns:p14="http://schemas.microsoft.com/office/powerpoint/2010/main" val="3017300939"/>
+      </p:ext>
+    </p:extLst>
+  </p:cSld>
+  <p:clrMapOvr>
+    <a:masterClrMapping/>
+  </p:clrMapOvr>
+</p:sld>
+</file>
+
+<file path=ppt/slides/slide2.xml><?xml version="1.0" encoding="utf-8"?>
+<p:sld xmlns:a="http://schemas.openxmlformats.org/drawingml/2006/main" xmlns:r="http://schemas.openxmlformats.org/officeDocument/2006/relationships" xmlns:p="http://schemas.openxmlformats.org/presentationml/2006/main">
+  <p:cSld>
+    <p:spTree>
+      <p:nvGrpSpPr>
+        <p:cNvPr id="1" name="">
+          <a:extLst>
+            <a:ext uri="{FF2B5EF4-FFF2-40B4-BE49-F238E27FC236}">
+              <a16:creationId xmlns:a16="http://schemas.microsoft.com/office/drawing/2014/main" id="{3FE57561-B756-5E54-7B53-AA825BB8596D}"/>
+            </a:ext>
+          </a:extLst>
+        </p:cNvPr>
+        <p:cNvGrpSpPr/>
+        <p:nvPr/>
+      </p:nvGrpSpPr>
+      <p:grpSpPr>
+        <a:xfrm>
+          <a:off x="0" y="0"/>
+          <a:ext cx="0" cy="0"/>
+          <a:chOff x="0" y="0"/>
+          <a:chExt cx="0" cy="0"/>
+        </a:xfrm>
+      </p:grpSpPr>
+      <p:grpSp>
+        <p:nvGrpSpPr>
+          <p:cNvPr id="2" name="Group 1">
             <a:extLst>
               <a:ext uri="{FF2B5EF4-FFF2-40B4-BE49-F238E27FC236}">
-                <a16:creationId xmlns:a16="http://schemas.microsoft.com/office/drawing/2014/main" id="{80CD5B00-F314-4CAF-82A6-EF0535CB6B94}"/>
-              </a:ext>
-            </a:extLst>
-          </p:cNvPr>
-          <p:cNvSpPr/>
-          <p:nvPr/>
-        </p:nvSpPr>
-        <p:spPr>
-          <a:xfrm>
-            <a:off x="4906523" y="916702"/>
-            <a:ext cx="1119673" cy="1119673"/>
-          </a:xfrm>
-          <a:prstGeom prst="ellipse">
-            <a:avLst/>
-          </a:prstGeom>
-          <a:solidFill>
-            <a:schemeClr val="accent4">
-              <a:lumMod val="20000"/>
-              <a:lumOff val="80000"/>
-            </a:schemeClr>
-          </a:solidFill>
-          <a:ln>
-            <a:noFill/>
-          </a:ln>
-        </p:spPr>
-        <p:style>
-          <a:lnRef idx="2">
-            <a:schemeClr val="accent1">
-              <a:shade val="50000"/>
-            </a:schemeClr>
-          </a:lnRef>
-          <a:fillRef idx="1">
-            <a:schemeClr val="accent1"/>
-          </a:fillRef>
-          <a:effectRef idx="0">
-            <a:schemeClr val="accent1"/>
-          </a:effectRef>
-          <a:fontRef idx="minor">
-            <a:schemeClr val="lt1"/>
-          </a:fontRef>
-        </p:style>
-        <p:txBody>
-          <a:bodyPr rtlCol="0" anchor="ctr"/>
-          <a:lstStyle/>
-          <a:p>
-            <a:pPr algn="ctr"/>
-            <a:endParaRPr lang="en-GB"/>
-          </a:p>
-        </p:txBody>
-      </p:sp>
-      <p:sp>
-        <p:nvSpPr>
-          <p:cNvPr id="24" name="Oval 23">
-            <a:extLst>
-              <a:ext uri="{FF2B5EF4-FFF2-40B4-BE49-F238E27FC236}">
-                <a16:creationId xmlns:a16="http://schemas.microsoft.com/office/drawing/2014/main" id="{6520C1F8-43B3-4D0B-9FB1-59752F2EB2E7}"/>
-              </a:ext>
-            </a:extLst>
-          </p:cNvPr>
-          <p:cNvSpPr/>
-          <p:nvPr/>
-        </p:nvSpPr>
-        <p:spPr>
-          <a:xfrm>
-            <a:off x="3319885" y="1868419"/>
-            <a:ext cx="545839" cy="545839"/>
-          </a:xfrm>
-          <a:prstGeom prst="ellipse">
-            <a:avLst/>
-          </a:prstGeom>
-          <a:solidFill>
-            <a:schemeClr val="accent3">
-              <a:lumMod val="60000"/>
-              <a:lumOff val="40000"/>
-            </a:schemeClr>
-          </a:solidFill>
-          <a:ln w="28575">
-            <a:solidFill>
-              <a:schemeClr val="tx1"/>
-            </a:solidFill>
-          </a:ln>
-        </p:spPr>
-        <p:style>
-          <a:lnRef idx="2">
-            <a:schemeClr val="accent1">
-              <a:shade val="50000"/>
-            </a:schemeClr>
-          </a:lnRef>
-          <a:fillRef idx="1">
-            <a:schemeClr val="accent1"/>
-          </a:fillRef>
-          <a:effectRef idx="0">
-            <a:schemeClr val="accent1"/>
-          </a:effectRef>
-          <a:fontRef idx="minor">
-            <a:schemeClr val="lt1"/>
-          </a:fontRef>
-        </p:style>
-        <p:txBody>
-          <a:bodyPr rtlCol="0" anchor="ctr"/>
-          <a:lstStyle/>
-          <a:p>
-            <a:pPr algn="ctr"/>
-            <a:endParaRPr lang="en-GB"/>
-          </a:p>
-        </p:txBody>
-      </p:sp>
-      <p:sp>
-        <p:nvSpPr>
-          <p:cNvPr id="26" name="Oval 25">
-            <a:extLst>
-              <a:ext uri="{FF2B5EF4-FFF2-40B4-BE49-F238E27FC236}">
-                <a16:creationId xmlns:a16="http://schemas.microsoft.com/office/drawing/2014/main" id="{EC7F3AB6-9C76-4B0B-8C64-E7E23D692BCE}"/>
-              </a:ext>
-            </a:extLst>
-          </p:cNvPr>
-          <p:cNvSpPr/>
-          <p:nvPr/>
-        </p:nvSpPr>
-        <p:spPr>
-          <a:xfrm>
-            <a:off x="3510147" y="2037529"/>
-            <a:ext cx="545839" cy="545839"/>
-          </a:xfrm>
-          <a:prstGeom prst="ellipse">
-            <a:avLst/>
-          </a:prstGeom>
-          <a:solidFill>
-            <a:schemeClr val="accent3">
-              <a:lumMod val="60000"/>
-              <a:lumOff val="40000"/>
-            </a:schemeClr>
-          </a:solidFill>
-          <a:ln w="28575">
-            <a:solidFill>
-              <a:schemeClr val="tx1"/>
-            </a:solidFill>
-          </a:ln>
-        </p:spPr>
-        <p:style>
-          <a:lnRef idx="2">
-            <a:schemeClr val="accent1">
-              <a:shade val="50000"/>
-            </a:schemeClr>
-          </a:lnRef>
-          <a:fillRef idx="1">
-            <a:schemeClr val="accent1"/>
-          </a:fillRef>
-          <a:effectRef idx="0">
-            <a:schemeClr val="accent1"/>
-          </a:effectRef>
-          <a:fontRef idx="minor">
-            <a:schemeClr val="lt1"/>
-          </a:fontRef>
-        </p:style>
-        <p:txBody>
-          <a:bodyPr rtlCol="0" anchor="ctr"/>
-          <a:lstStyle/>
-          <a:p>
-            <a:pPr algn="ctr"/>
-            <a:endParaRPr lang="en-GB"/>
-          </a:p>
-        </p:txBody>
-      </p:sp>
-      <p:sp>
-        <p:nvSpPr>
-          <p:cNvPr id="27" name="Oval 26">
-            <a:extLst>
-              <a:ext uri="{FF2B5EF4-FFF2-40B4-BE49-F238E27FC236}">
-                <a16:creationId xmlns:a16="http://schemas.microsoft.com/office/drawing/2014/main" id="{5A628F2C-397F-4E4D-AD97-BE652C65B6EE}"/>
-              </a:ext>
-            </a:extLst>
-          </p:cNvPr>
-          <p:cNvSpPr/>
-          <p:nvPr/>
-        </p:nvSpPr>
-        <p:spPr>
-          <a:xfrm>
-            <a:off x="2725172" y="3161861"/>
-            <a:ext cx="545839" cy="545839"/>
-          </a:xfrm>
-          <a:prstGeom prst="ellipse">
-            <a:avLst/>
-          </a:prstGeom>
-          <a:solidFill>
-            <a:schemeClr val="accent3">
-              <a:lumMod val="60000"/>
-              <a:lumOff val="40000"/>
-            </a:schemeClr>
-          </a:solidFill>
-          <a:ln w="28575">
-            <a:solidFill>
-              <a:schemeClr val="tx1"/>
-            </a:solidFill>
-          </a:ln>
-        </p:spPr>
-        <p:style>
-          <a:lnRef idx="2">
-            <a:schemeClr val="accent1">
-              <a:shade val="50000"/>
-            </a:schemeClr>
-          </a:lnRef>
-          <a:fillRef idx="1">
-            <a:schemeClr val="accent1"/>
-          </a:fillRef>
-          <a:effectRef idx="0">
-            <a:schemeClr val="accent1"/>
-          </a:effectRef>
-          <a:fontRef idx="minor">
-            <a:schemeClr val="lt1"/>
-          </a:fontRef>
-        </p:style>
-        <p:txBody>
-          <a:bodyPr rtlCol="0" anchor="ctr"/>
-          <a:lstStyle/>
-          <a:p>
-            <a:pPr algn="ctr"/>
-            <a:endParaRPr lang="en-GB"/>
-          </a:p>
-        </p:txBody>
-      </p:sp>
-      <p:sp>
-        <p:nvSpPr>
-          <p:cNvPr id="28" name="Oval 27">
-            <a:extLst>
-              <a:ext uri="{FF2B5EF4-FFF2-40B4-BE49-F238E27FC236}">
-                <a16:creationId xmlns:a16="http://schemas.microsoft.com/office/drawing/2014/main" id="{C79CDAEA-C9B8-4E4B-9B1F-31898B4E1630}"/>
-              </a:ext>
-            </a:extLst>
-          </p:cNvPr>
-          <p:cNvSpPr/>
-          <p:nvPr/>
-        </p:nvSpPr>
-        <p:spPr>
-          <a:xfrm>
-            <a:off x="3320518" y="3762549"/>
-            <a:ext cx="545839" cy="545839"/>
-          </a:xfrm>
-          <a:prstGeom prst="ellipse">
-            <a:avLst/>
-          </a:prstGeom>
-          <a:solidFill>
-            <a:schemeClr val="accent3">
-              <a:lumMod val="60000"/>
-              <a:lumOff val="40000"/>
-            </a:schemeClr>
-          </a:solidFill>
-          <a:ln w="28575">
-            <a:solidFill>
-              <a:schemeClr val="tx1"/>
-            </a:solidFill>
-          </a:ln>
-        </p:spPr>
-        <p:style>
-          <a:lnRef idx="2">
-            <a:schemeClr val="accent1">
-              <a:shade val="50000"/>
-            </a:schemeClr>
-          </a:lnRef>
-          <a:fillRef idx="1">
-            <a:schemeClr val="accent1"/>
-          </a:fillRef>
-          <a:effectRef idx="0">
-            <a:schemeClr val="accent1"/>
-          </a:effectRef>
-          <a:fontRef idx="minor">
-            <a:schemeClr val="lt1"/>
-          </a:fontRef>
-        </p:style>
-        <p:txBody>
-          <a:bodyPr rtlCol="0" anchor="ctr"/>
-          <a:lstStyle/>
-          <a:p>
-            <a:pPr algn="ctr"/>
-            <a:endParaRPr lang="en-GB"/>
-          </a:p>
-        </p:txBody>
-      </p:sp>
-      <p:sp>
-        <p:nvSpPr>
-          <p:cNvPr id="29" name="Oval 28">
-            <a:extLst>
-              <a:ext uri="{FF2B5EF4-FFF2-40B4-BE49-F238E27FC236}">
-                <a16:creationId xmlns:a16="http://schemas.microsoft.com/office/drawing/2014/main" id="{A0017855-39F4-4B1A-BEE6-4512CC9641D4}"/>
-              </a:ext>
-            </a:extLst>
-          </p:cNvPr>
-          <p:cNvSpPr/>
-          <p:nvPr/>
-        </p:nvSpPr>
-        <p:spPr>
-          <a:xfrm>
-            <a:off x="3487542" y="3643552"/>
-            <a:ext cx="545839" cy="545839"/>
-          </a:xfrm>
-          <a:prstGeom prst="ellipse">
-            <a:avLst/>
-          </a:prstGeom>
-          <a:solidFill>
-            <a:schemeClr val="accent3">
-              <a:lumMod val="60000"/>
-              <a:lumOff val="40000"/>
-            </a:schemeClr>
-          </a:solidFill>
-          <a:ln w="28575">
-            <a:solidFill>
-              <a:schemeClr val="tx1"/>
-            </a:solidFill>
-          </a:ln>
-        </p:spPr>
-        <p:style>
-          <a:lnRef idx="2">
-            <a:schemeClr val="accent1">
-              <a:shade val="50000"/>
-            </a:schemeClr>
-          </a:lnRef>
-          <a:fillRef idx="1">
-            <a:schemeClr val="accent1"/>
-          </a:fillRef>
-          <a:effectRef idx="0">
-            <a:schemeClr val="accent1"/>
-          </a:effectRef>
-          <a:fontRef idx="minor">
-            <a:schemeClr val="lt1"/>
-          </a:fontRef>
-        </p:style>
-        <p:txBody>
-          <a:bodyPr rtlCol="0" anchor="ctr"/>
-          <a:lstStyle/>
-          <a:p>
-            <a:pPr algn="ctr"/>
-            <a:endParaRPr lang="en-GB"/>
-          </a:p>
-        </p:txBody>
-      </p:sp>
-      <p:sp>
-        <p:nvSpPr>
-          <p:cNvPr id="30" name="Oval 29">
-            <a:extLst>
-              <a:ext uri="{FF2B5EF4-FFF2-40B4-BE49-F238E27FC236}">
-                <a16:creationId xmlns:a16="http://schemas.microsoft.com/office/drawing/2014/main" id="{4588A90D-B319-4535-A0AF-6D408185B262}"/>
-              </a:ext>
-            </a:extLst>
-          </p:cNvPr>
-          <p:cNvSpPr/>
-          <p:nvPr/>
-        </p:nvSpPr>
-        <p:spPr>
-          <a:xfrm>
-            <a:off x="4523144" y="3729820"/>
-            <a:ext cx="545839" cy="545839"/>
-          </a:xfrm>
-          <a:prstGeom prst="ellipse">
-            <a:avLst/>
-          </a:prstGeom>
-          <a:solidFill>
-            <a:schemeClr val="accent3">
-              <a:lumMod val="60000"/>
-              <a:lumOff val="40000"/>
-            </a:schemeClr>
-          </a:solidFill>
-          <a:ln w="28575">
-            <a:solidFill>
-              <a:schemeClr val="tx1"/>
-            </a:solidFill>
-          </a:ln>
-        </p:spPr>
-        <p:style>
-          <a:lnRef idx="2">
-            <a:schemeClr val="accent1">
-              <a:shade val="50000"/>
-            </a:schemeClr>
-          </a:lnRef>
-          <a:fillRef idx="1">
-            <a:schemeClr val="accent1"/>
-          </a:fillRef>
-          <a:effectRef idx="0">
-            <a:schemeClr val="accent1"/>
-          </a:effectRef>
-          <a:fontRef idx="minor">
-            <a:schemeClr val="lt1"/>
-          </a:fontRef>
-        </p:style>
-        <p:txBody>
-          <a:bodyPr rtlCol="0" anchor="ctr"/>
-          <a:lstStyle/>
-          <a:p>
-            <a:pPr algn="ctr"/>
-            <a:endParaRPr lang="en-GB"/>
-          </a:p>
-        </p:txBody>
-      </p:sp>
-      <p:sp>
-        <p:nvSpPr>
-          <p:cNvPr id="31" name="Oval 30">
-            <a:extLst>
-              <a:ext uri="{FF2B5EF4-FFF2-40B4-BE49-F238E27FC236}">
-                <a16:creationId xmlns:a16="http://schemas.microsoft.com/office/drawing/2014/main" id="{C5B97CCF-261D-46B5-9D24-A191DC43165C}"/>
-              </a:ext>
-            </a:extLst>
-          </p:cNvPr>
-          <p:cNvSpPr/>
-          <p:nvPr/>
-        </p:nvSpPr>
-        <p:spPr>
-          <a:xfrm>
-            <a:off x="4753081" y="1965209"/>
-            <a:ext cx="545839" cy="545839"/>
-          </a:xfrm>
-          <a:prstGeom prst="ellipse">
-            <a:avLst/>
-          </a:prstGeom>
-          <a:solidFill>
-            <a:schemeClr val="accent3">
-              <a:lumMod val="60000"/>
-              <a:lumOff val="40000"/>
-            </a:schemeClr>
-          </a:solidFill>
-          <a:ln w="28575">
-            <a:solidFill>
-              <a:schemeClr val="tx1"/>
-            </a:solidFill>
-          </a:ln>
-        </p:spPr>
-        <p:style>
-          <a:lnRef idx="2">
-            <a:schemeClr val="accent1">
-              <a:shade val="50000"/>
-            </a:schemeClr>
-          </a:lnRef>
-          <a:fillRef idx="1">
-            <a:schemeClr val="accent1"/>
-          </a:fillRef>
-          <a:effectRef idx="0">
-            <a:schemeClr val="accent1"/>
-          </a:effectRef>
-          <a:fontRef idx="minor">
-            <a:schemeClr val="lt1"/>
-          </a:fontRef>
-        </p:style>
-        <p:txBody>
-          <a:bodyPr rtlCol="0" anchor="ctr"/>
-          <a:lstStyle/>
-          <a:p>
-            <a:pPr algn="ctr"/>
-            <a:endParaRPr lang="en-GB"/>
-          </a:p>
-        </p:txBody>
-      </p:sp>
-      <p:grpSp>
-        <p:nvGrpSpPr>
-          <p:cNvPr id="37" name="Group 36">
-            <a:extLst>
-              <a:ext uri="{FF2B5EF4-FFF2-40B4-BE49-F238E27FC236}">
-                <a16:creationId xmlns:a16="http://schemas.microsoft.com/office/drawing/2014/main" id="{95A9416A-F183-4ED4-B5D5-D212752E468E}"/>
+                <a16:creationId xmlns:a16="http://schemas.microsoft.com/office/drawing/2014/main" id="{52EBF011-62AC-379E-E033-E6D55D5A1213}"/>
               </a:ext>
             </a:extLst>
           </p:cNvPr>
@@ -4324,18 +3437,18 @@
         </p:nvGrpSpPr>
         <p:grpSpPr>
           <a:xfrm>
-            <a:off x="6896031" y="179750"/>
-            <a:ext cx="411060" cy="335588"/>
-            <a:chOff x="8330268" y="775676"/>
-            <a:chExt cx="411060" cy="335588"/>
+            <a:off x="1387185" y="313458"/>
+            <a:ext cx="6369628" cy="6231083"/>
+            <a:chOff x="1387185" y="313458"/>
+            <a:chExt cx="6369628" cy="6231083"/>
           </a:xfrm>
         </p:grpSpPr>
         <p:sp>
           <p:nvSpPr>
-            <p:cNvPr id="34" name="Rectangle 33">
+            <p:cNvPr id="6" name="Oval 5">
               <a:extLst>
                 <a:ext uri="{FF2B5EF4-FFF2-40B4-BE49-F238E27FC236}">
-                  <a16:creationId xmlns:a16="http://schemas.microsoft.com/office/drawing/2014/main" id="{619B3C31-D11D-4DCB-8AC0-3C40D6147D63}"/>
+                  <a16:creationId xmlns:a16="http://schemas.microsoft.com/office/drawing/2014/main" id="{8E117558-9693-C413-7744-F8EE75C38C3E}"/>
                 </a:ext>
               </a:extLst>
             </p:cNvPr>
@@ -4343,26 +3456,29 @@
             <p:nvPr/>
           </p:nvSpPr>
           <p:spPr>
-            <a:xfrm flipV="1">
-              <a:off x="8330268" y="775676"/>
-              <a:ext cx="411060" cy="78049"/>
+            <a:xfrm>
+              <a:off x="3855026" y="313458"/>
+              <a:ext cx="1433946" cy="1433946"/>
             </a:xfrm>
-            <a:prstGeom prst="rect">
+            <a:prstGeom prst="ellipse">
               <a:avLst/>
             </a:prstGeom>
-            <a:solidFill>
-              <a:schemeClr val="bg2">
-                <a:lumMod val="75000"/>
-              </a:schemeClr>
-            </a:solidFill>
-            <a:ln>
-              <a:noFill/>
+            <a:blipFill>
+              <a:blip r:embed="rId2"/>
+              <a:stretch>
+                <a:fillRect/>
+              </a:stretch>
+            </a:blipFill>
+            <a:ln w="28575">
+              <a:solidFill>
+                <a:schemeClr val="tx1"/>
+              </a:solidFill>
             </a:ln>
           </p:spPr>
           <p:style>
             <a:lnRef idx="2">
               <a:schemeClr val="accent1">
-                <a:shade val="50000"/>
+                <a:shade val="15000"/>
               </a:schemeClr>
             </a:lnRef>
             <a:fillRef idx="1">
@@ -4386,10 +3502,10 @@
         </p:sp>
         <p:sp>
           <p:nvSpPr>
-            <p:cNvPr id="35" name="Rectangle 34">
+            <p:cNvPr id="14" name="Oval 13">
               <a:extLst>
                 <a:ext uri="{FF2B5EF4-FFF2-40B4-BE49-F238E27FC236}">
-                  <a16:creationId xmlns:a16="http://schemas.microsoft.com/office/drawing/2014/main" id="{5A118C4B-786D-4DB1-B5CB-4965FBE53B59}"/>
+                  <a16:creationId xmlns:a16="http://schemas.microsoft.com/office/drawing/2014/main" id="{8F6D5AEC-1761-6A9D-4136-CF1EA5520AAC}"/>
                 </a:ext>
               </a:extLst>
             </p:cNvPr>
@@ -4397,26 +3513,86 @@
             <p:nvPr/>
           </p:nvSpPr>
           <p:spPr>
-            <a:xfrm flipV="1">
-              <a:off x="8330268" y="905428"/>
-              <a:ext cx="411060" cy="78049"/>
+            <a:xfrm>
+              <a:off x="5605894" y="1030431"/>
+              <a:ext cx="1433946" cy="1433946"/>
             </a:xfrm>
-            <a:prstGeom prst="rect">
+            <a:prstGeom prst="ellipse">
               <a:avLst/>
             </a:prstGeom>
-            <a:solidFill>
-              <a:schemeClr val="bg2">
-                <a:lumMod val="75000"/>
-              </a:schemeClr>
-            </a:solidFill>
-            <a:ln>
-              <a:noFill/>
+            <a:blipFill>
+              <a:blip r:embed="rId3"/>
+              <a:stretch>
+                <a:fillRect/>
+              </a:stretch>
+            </a:blipFill>
+            <a:ln w="28575">
+              <a:solidFill>
+                <a:schemeClr val="tx1"/>
+              </a:solidFill>
             </a:ln>
           </p:spPr>
           <p:style>
             <a:lnRef idx="2">
               <a:schemeClr val="accent1">
-                <a:shade val="50000"/>
+                <a:shade val="15000"/>
+              </a:schemeClr>
+            </a:lnRef>
+            <a:fillRef idx="1">
+              <a:schemeClr val="accent1"/>
+            </a:fillRef>
+            <a:effectRef idx="0">
+              <a:schemeClr val="accent1"/>
+            </a:effectRef>
+            <a:fontRef idx="minor">
+              <a:schemeClr val="lt1"/>
+            </a:fontRef>
+          </p:style>
+          <p:txBody>
+            <a:bodyPr rtlCol="0" anchor="ctr"/>
+            <a:lstStyle/>
+            <a:p>
+              <a:pPr algn="ctr"/>
+              <a:endParaRPr lang="en-GB" dirty="0"/>
+            </a:p>
+          </p:txBody>
+        </p:sp>
+        <p:sp>
+          <p:nvSpPr>
+            <p:cNvPr id="15" name="Oval 14">
+              <a:extLst>
+                <a:ext uri="{FF2B5EF4-FFF2-40B4-BE49-F238E27FC236}">
+                  <a16:creationId xmlns:a16="http://schemas.microsoft.com/office/drawing/2014/main" id="{343E613B-2769-EDD1-685D-4DA434A9F76F}"/>
+                </a:ext>
+              </a:extLst>
+            </p:cNvPr>
+            <p:cNvSpPr/>
+            <p:nvPr/>
+          </p:nvSpPr>
+          <p:spPr>
+            <a:xfrm>
+              <a:off x="6322867" y="2712026"/>
+              <a:ext cx="1433946" cy="1433946"/>
+            </a:xfrm>
+            <a:prstGeom prst="ellipse">
+              <a:avLst/>
+            </a:prstGeom>
+            <a:blipFill>
+              <a:blip r:embed="rId4"/>
+              <a:stretch>
+                <a:fillRect/>
+              </a:stretch>
+            </a:blipFill>
+            <a:ln w="28575">
+              <a:solidFill>
+                <a:schemeClr val="tx1"/>
+              </a:solidFill>
+            </a:ln>
+          </p:spPr>
+          <p:style>
+            <a:lnRef idx="2">
+              <a:schemeClr val="accent1">
+                <a:shade val="15000"/>
               </a:schemeClr>
             </a:lnRef>
             <a:fillRef idx="1">
@@ -4440,10 +3616,10 @@
         </p:sp>
         <p:sp>
           <p:nvSpPr>
-            <p:cNvPr id="36" name="Rectangle 35">
+            <p:cNvPr id="16" name="Oval 15">
               <a:extLst>
                 <a:ext uri="{FF2B5EF4-FFF2-40B4-BE49-F238E27FC236}">
-                  <a16:creationId xmlns:a16="http://schemas.microsoft.com/office/drawing/2014/main" id="{AB892B74-4F89-47E5-A4BA-C5B1A7A46AFB}"/>
+                  <a16:creationId xmlns:a16="http://schemas.microsoft.com/office/drawing/2014/main" id="{436D3FA6-9157-5C84-A8F2-2C30E295B3E9}"/>
                 </a:ext>
               </a:extLst>
             </p:cNvPr>
@@ -4451,26 +3627,29 @@
             <p:nvPr/>
           </p:nvSpPr>
           <p:spPr>
-            <a:xfrm flipV="1">
-              <a:off x="8330268" y="1033215"/>
-              <a:ext cx="411060" cy="78049"/>
+            <a:xfrm>
+              <a:off x="5605894" y="4393621"/>
+              <a:ext cx="1433946" cy="1433946"/>
             </a:xfrm>
-            <a:prstGeom prst="rect">
+            <a:prstGeom prst="ellipse">
               <a:avLst/>
             </a:prstGeom>
-            <a:solidFill>
-              <a:schemeClr val="bg2">
-                <a:lumMod val="75000"/>
-              </a:schemeClr>
-            </a:solidFill>
-            <a:ln>
-              <a:noFill/>
+            <a:blipFill>
+              <a:blip r:embed="rId5"/>
+              <a:stretch>
+                <a:fillRect/>
+              </a:stretch>
+            </a:blipFill>
+            <a:ln w="28575">
+              <a:solidFill>
+                <a:schemeClr val="tx1"/>
+              </a:solidFill>
             </a:ln>
           </p:spPr>
           <p:style>
             <a:lnRef idx="2">
               <a:schemeClr val="accent1">
-                <a:shade val="50000"/>
+                <a:shade val="15000"/>
               </a:schemeClr>
             </a:lnRef>
             <a:fillRef idx="1">
@@ -4492,33 +3671,12 @@
             </a:p>
           </p:txBody>
         </p:sp>
-      </p:grpSp>
-      <p:grpSp>
-        <p:nvGrpSpPr>
-          <p:cNvPr id="42" name="Group 41">
-            <a:extLst>
-              <a:ext uri="{FF2B5EF4-FFF2-40B4-BE49-F238E27FC236}">
-                <a16:creationId xmlns:a16="http://schemas.microsoft.com/office/drawing/2014/main" id="{4062BB5F-395B-48FF-A309-D43892EEBB16}"/>
-              </a:ext>
-            </a:extLst>
-          </p:cNvPr>
-          <p:cNvGrpSpPr/>
-          <p:nvPr/>
-        </p:nvGrpSpPr>
-        <p:grpSpPr>
-          <a:xfrm>
-            <a:off x="6408754" y="142014"/>
-            <a:ext cx="411060" cy="411060"/>
-            <a:chOff x="7101561" y="916702"/>
-            <a:chExt cx="411060" cy="411060"/>
-          </a:xfrm>
-        </p:grpSpPr>
         <p:sp>
           <p:nvSpPr>
-            <p:cNvPr id="38" name="Cross 37">
+            <p:cNvPr id="17" name="Oval 16">
               <a:extLst>
                 <a:ext uri="{FF2B5EF4-FFF2-40B4-BE49-F238E27FC236}">
-                  <a16:creationId xmlns:a16="http://schemas.microsoft.com/office/drawing/2014/main" id="{5B005CAD-E544-49D4-AD6F-698345FDB73B}"/>
+                  <a16:creationId xmlns:a16="http://schemas.microsoft.com/office/drawing/2014/main" id="{6D4AA900-D9FB-23B0-C39F-E43846FCBFB9}"/>
                 </a:ext>
               </a:extLst>
             </p:cNvPr>
@@ -4527,27 +3685,142 @@
           </p:nvSpPr>
           <p:spPr>
             <a:xfrm>
-              <a:off x="7101561" y="916702"/>
-              <a:ext cx="411060" cy="411060"/>
+              <a:off x="3855026" y="5110595"/>
+              <a:ext cx="1433946" cy="1433946"/>
             </a:xfrm>
-            <a:prstGeom prst="plus">
-              <a:avLst>
-                <a:gd name="adj" fmla="val 38680"/>
-              </a:avLst>
+            <a:prstGeom prst="ellipse">
+              <a:avLst/>
             </a:prstGeom>
-            <a:solidFill>
-              <a:schemeClr val="bg2">
-                <a:lumMod val="75000"/>
-              </a:schemeClr>
-            </a:solidFill>
-            <a:ln>
-              <a:noFill/>
+            <a:blipFill>
+              <a:blip r:embed="rId6"/>
+              <a:stretch>
+                <a:fillRect/>
+              </a:stretch>
+            </a:blipFill>
+            <a:ln w="28575">
+              <a:solidFill>
+                <a:schemeClr val="tx1"/>
+              </a:solidFill>
             </a:ln>
           </p:spPr>
           <p:style>
             <a:lnRef idx="2">
               <a:schemeClr val="accent1">
-                <a:shade val="50000"/>
+                <a:shade val="15000"/>
+              </a:schemeClr>
+            </a:lnRef>
+            <a:fillRef idx="1">
+              <a:schemeClr val="accent1"/>
+            </a:fillRef>
+            <a:effectRef idx="0">
+              <a:schemeClr val="accent1"/>
+            </a:effectRef>
+            <a:fontRef idx="minor">
+              <a:schemeClr val="lt1"/>
+            </a:fontRef>
+          </p:style>
+          <p:txBody>
+            <a:bodyPr rtlCol="0" anchor="ctr"/>
+            <a:lstStyle/>
+            <a:p>
+              <a:pPr algn="ctr"/>
+              <a:endParaRPr lang="en-GB"/>
+            </a:p>
+          </p:txBody>
+        </p:sp>
+        <p:sp>
+          <p:nvSpPr>
+            <p:cNvPr id="18" name="Oval 17">
+              <a:extLst>
+                <a:ext uri="{FF2B5EF4-FFF2-40B4-BE49-F238E27FC236}">
+                  <a16:creationId xmlns:a16="http://schemas.microsoft.com/office/drawing/2014/main" id="{CD22C00E-1F53-279F-C28A-02DF3A951F55}"/>
+                </a:ext>
+              </a:extLst>
+            </p:cNvPr>
+            <p:cNvSpPr/>
+            <p:nvPr/>
+          </p:nvSpPr>
+          <p:spPr>
+            <a:xfrm>
+              <a:off x="2104158" y="1030431"/>
+              <a:ext cx="1433946" cy="1433946"/>
+            </a:xfrm>
+            <a:prstGeom prst="ellipse">
+              <a:avLst/>
+            </a:prstGeom>
+            <a:blipFill>
+              <a:blip r:embed="rId7"/>
+              <a:stretch>
+                <a:fillRect/>
+              </a:stretch>
+            </a:blipFill>
+            <a:ln w="28575">
+              <a:solidFill>
+                <a:schemeClr val="tx1"/>
+              </a:solidFill>
+            </a:ln>
+          </p:spPr>
+          <p:style>
+            <a:lnRef idx="2">
+              <a:schemeClr val="accent1">
+                <a:shade val="15000"/>
+              </a:schemeClr>
+            </a:lnRef>
+            <a:fillRef idx="1">
+              <a:schemeClr val="accent1"/>
+            </a:fillRef>
+            <a:effectRef idx="0">
+              <a:schemeClr val="accent1"/>
+            </a:effectRef>
+            <a:fontRef idx="minor">
+              <a:schemeClr val="lt1"/>
+            </a:fontRef>
+          </p:style>
+          <p:txBody>
+            <a:bodyPr rtlCol="0" anchor="ctr"/>
+            <a:lstStyle/>
+            <a:p>
+              <a:pPr algn="ctr"/>
+              <a:endParaRPr lang="en-GB"/>
+            </a:p>
+          </p:txBody>
+        </p:sp>
+        <p:sp>
+          <p:nvSpPr>
+            <p:cNvPr id="19" name="Oval 18">
+              <a:extLst>
+                <a:ext uri="{FF2B5EF4-FFF2-40B4-BE49-F238E27FC236}">
+                  <a16:creationId xmlns:a16="http://schemas.microsoft.com/office/drawing/2014/main" id="{BAD30E0B-2F31-A5CB-2180-124E79DD7364}"/>
+                </a:ext>
+              </a:extLst>
+            </p:cNvPr>
+            <p:cNvSpPr/>
+            <p:nvPr/>
+          </p:nvSpPr>
+          <p:spPr>
+            <a:xfrm>
+              <a:off x="1387185" y="2712026"/>
+              <a:ext cx="1433946" cy="1433946"/>
+            </a:xfrm>
+            <a:prstGeom prst="ellipse">
+              <a:avLst/>
+            </a:prstGeom>
+            <a:blipFill>
+              <a:blip r:embed="rId8"/>
+              <a:stretch>
+                <a:fillRect/>
+              </a:stretch>
+            </a:blipFill>
+            <a:ln w="28575">
+              <a:solidFill>
+                <a:schemeClr val="tx1"/>
+              </a:solidFill>
+            </a:ln>
+          </p:spPr>
+          <p:style>
+            <a:lnRef idx="2">
+              <a:schemeClr val="accent1">
+                <a:shade val="15000"/>
               </a:schemeClr>
             </a:lnRef>
             <a:fillRef idx="1">
@@ -4571,10 +3844,10 @@
         </p:sp>
         <p:sp>
           <p:nvSpPr>
-            <p:cNvPr id="40" name="Cross 39">
+            <p:cNvPr id="20" name="Oval 19">
               <a:extLst>
                 <a:ext uri="{FF2B5EF4-FFF2-40B4-BE49-F238E27FC236}">
-                  <a16:creationId xmlns:a16="http://schemas.microsoft.com/office/drawing/2014/main" id="{360F641D-FB62-4FA3-BD49-3DABF3122515}"/>
+                  <a16:creationId xmlns:a16="http://schemas.microsoft.com/office/drawing/2014/main" id="{605A81D4-4CA1-95DD-1D40-C37F8A3CC11D}"/>
                 </a:ext>
               </a:extLst>
             </p:cNvPr>
@@ -4582,28 +3855,428 @@
             <p:nvPr/>
           </p:nvSpPr>
           <p:spPr>
-            <a:xfrm rot="2849300">
-              <a:off x="7101561" y="916702"/>
-              <a:ext cx="411060" cy="411060"/>
+            <a:xfrm>
+              <a:off x="2104157" y="4393621"/>
+              <a:ext cx="1433946" cy="1433946"/>
             </a:xfrm>
-            <a:prstGeom prst="plus">
-              <a:avLst>
-                <a:gd name="adj" fmla="val 39190"/>
-              </a:avLst>
+            <a:prstGeom prst="ellipse">
+              <a:avLst/>
             </a:prstGeom>
-            <a:solidFill>
-              <a:schemeClr val="bg2">
-                <a:lumMod val="75000"/>
-              </a:schemeClr>
-            </a:solidFill>
-            <a:ln>
-              <a:noFill/>
+            <a:blipFill>
+              <a:blip r:embed="rId9"/>
+              <a:stretch>
+                <a:fillRect/>
+              </a:stretch>
+            </a:blipFill>
+            <a:ln w="28575">
+              <a:solidFill>
+                <a:schemeClr val="tx1"/>
+              </a:solidFill>
             </a:ln>
           </p:spPr>
           <p:style>
             <a:lnRef idx="2">
               <a:schemeClr val="accent1">
-                <a:shade val="50000"/>
+                <a:shade val="15000"/>
+              </a:schemeClr>
+            </a:lnRef>
+            <a:fillRef idx="1">
+              <a:schemeClr val="accent1"/>
+            </a:fillRef>
+            <a:effectRef idx="0">
+              <a:schemeClr val="accent1"/>
+            </a:effectRef>
+            <a:fontRef idx="minor">
+              <a:schemeClr val="lt1"/>
+            </a:fontRef>
+          </p:style>
+          <p:txBody>
+            <a:bodyPr rtlCol="0" anchor="ctr"/>
+            <a:lstStyle/>
+            <a:p>
+              <a:pPr algn="ctr"/>
+              <a:endParaRPr lang="en-GB"/>
+            </a:p>
+          </p:txBody>
+        </p:sp>
+      </p:grpSp>
+      <p:sp>
+        <p:nvSpPr>
+          <p:cNvPr id="35" name="Rectangle: Rounded Corners 34">
+            <a:extLst>
+              <a:ext uri="{FF2B5EF4-FFF2-40B4-BE49-F238E27FC236}">
+                <a16:creationId xmlns:a16="http://schemas.microsoft.com/office/drawing/2014/main" id="{228386B2-19A0-D9F7-8DA9-4C0C1FF548D4}"/>
+              </a:ext>
+            </a:extLst>
+          </p:cNvPr>
+          <p:cNvSpPr/>
+          <p:nvPr/>
+        </p:nvSpPr>
+        <p:spPr>
+          <a:xfrm>
+            <a:off x="10541576" y="313457"/>
+            <a:ext cx="2150919" cy="6231083"/>
+          </a:xfrm>
+          <a:prstGeom prst="roundRect">
+            <a:avLst/>
+          </a:prstGeom>
+          <a:solidFill>
+            <a:schemeClr val="accent1">
+              <a:lumMod val="20000"/>
+              <a:lumOff val="80000"/>
+            </a:schemeClr>
+          </a:solidFill>
+          <a:ln w="28575">
+            <a:solidFill>
+              <a:schemeClr val="tx1"/>
+            </a:solidFill>
+          </a:ln>
+        </p:spPr>
+        <p:style>
+          <a:lnRef idx="2">
+            <a:schemeClr val="accent1">
+              <a:shade val="15000"/>
+            </a:schemeClr>
+          </a:lnRef>
+          <a:fillRef idx="1">
+            <a:schemeClr val="accent1"/>
+          </a:fillRef>
+          <a:effectRef idx="0">
+            <a:schemeClr val="accent1"/>
+          </a:effectRef>
+          <a:fontRef idx="minor">
+            <a:schemeClr val="lt1"/>
+          </a:fontRef>
+        </p:style>
+        <p:txBody>
+          <a:bodyPr rtlCol="0" anchor="ctr"/>
+          <a:lstStyle/>
+          <a:p>
+            <a:pPr algn="ctr"/>
+            <a:endParaRPr lang="en-GB"/>
+          </a:p>
+        </p:txBody>
+      </p:sp>
+      <p:sp>
+        <p:nvSpPr>
+          <p:cNvPr id="36" name="Multiplication Sign 35">
+            <a:hlinkClick r:id="" action="ppaction://hlinkshowjump?jump=previousslide"/>
+            <a:extLst>
+              <a:ext uri="{FF2B5EF4-FFF2-40B4-BE49-F238E27FC236}">
+                <a16:creationId xmlns:a16="http://schemas.microsoft.com/office/drawing/2014/main" id="{1B8DCC00-8198-6E77-3477-A85522AFD270}"/>
+              </a:ext>
+            </a:extLst>
+          </p:cNvPr>
+          <p:cNvSpPr/>
+          <p:nvPr/>
+        </p:nvSpPr>
+        <p:spPr>
+          <a:xfrm>
+            <a:off x="11996140" y="329767"/>
+            <a:ext cx="673769" cy="673769"/>
+          </a:xfrm>
+          <a:prstGeom prst="mathMultiply">
+            <a:avLst/>
+          </a:prstGeom>
+          <a:solidFill>
+            <a:srgbClr val="FF0000"/>
+          </a:solidFill>
+          <a:ln>
+            <a:solidFill>
+              <a:srgbClr val="C00000"/>
+            </a:solidFill>
+          </a:ln>
+        </p:spPr>
+        <p:style>
+          <a:lnRef idx="2">
+            <a:schemeClr val="accent1">
+              <a:shade val="15000"/>
+            </a:schemeClr>
+          </a:lnRef>
+          <a:fillRef idx="1">
+            <a:schemeClr val="accent1"/>
+          </a:fillRef>
+          <a:effectRef idx="0">
+            <a:schemeClr val="accent1"/>
+          </a:effectRef>
+          <a:fontRef idx="minor">
+            <a:schemeClr val="lt1"/>
+          </a:fontRef>
+        </p:style>
+        <p:txBody>
+          <a:bodyPr rtlCol="0" anchor="ctr"/>
+          <a:lstStyle/>
+          <a:p>
+            <a:pPr algn="ctr"/>
+            <a:endParaRPr lang="en-GB"/>
+          </a:p>
+        </p:txBody>
+      </p:sp>
+      <p:sp>
+        <p:nvSpPr>
+          <p:cNvPr id="38" name="Arrow: Left 37">
+            <a:hlinkClick r:id="" action="ppaction://hlinkshowjump?jump=nextslide"/>
+            <a:extLst>
+              <a:ext uri="{FF2B5EF4-FFF2-40B4-BE49-F238E27FC236}">
+                <a16:creationId xmlns:a16="http://schemas.microsoft.com/office/drawing/2014/main" id="{F8AD20F2-8A38-2DCB-9999-D9DB0B92F8FC}"/>
+              </a:ext>
+            </a:extLst>
+          </p:cNvPr>
+          <p:cNvSpPr/>
+          <p:nvPr/>
+        </p:nvSpPr>
+        <p:spPr>
+          <a:xfrm>
+            <a:off x="8530936" y="476151"/>
+            <a:ext cx="519545" cy="381000"/>
+          </a:xfrm>
+          <a:prstGeom prst="leftArrow">
+            <a:avLst/>
+          </a:prstGeom>
+        </p:spPr>
+        <p:style>
+          <a:lnRef idx="2">
+            <a:schemeClr val="accent1">
+              <a:shade val="15000"/>
+            </a:schemeClr>
+          </a:lnRef>
+          <a:fillRef idx="1">
+            <a:schemeClr val="accent1"/>
+          </a:fillRef>
+          <a:effectRef idx="0">
+            <a:schemeClr val="accent1"/>
+          </a:effectRef>
+          <a:fontRef idx="minor">
+            <a:schemeClr val="lt1"/>
+          </a:fontRef>
+        </p:style>
+        <p:txBody>
+          <a:bodyPr rtlCol="0" anchor="ctr"/>
+          <a:lstStyle/>
+          <a:p>
+            <a:pPr algn="ctr"/>
+            <a:endParaRPr lang="en-GB"/>
+          </a:p>
+        </p:txBody>
+      </p:sp>
+    </p:spTree>
+    <p:extLst>
+      <p:ext uri="{BB962C8B-B14F-4D97-AF65-F5344CB8AC3E}">
+        <p14:creationId xmlns:p14="http://schemas.microsoft.com/office/powerpoint/2010/main" val="1431947877"/>
+      </p:ext>
+    </p:extLst>
+  </p:cSld>
+  <p:clrMapOvr>
+    <a:masterClrMapping/>
+  </p:clrMapOvr>
+  <mc:AlternateContent xmlns:mc="http://schemas.openxmlformats.org/markup-compatibility/2006" xmlns:p159="http://schemas.microsoft.com/office/powerpoint/2015/09/main">
+    <mc:Choice Requires="p159">
+      <p:transition>
+        <p159:morph option="byObject"/>
+      </p:transition>
+    </mc:Choice>
+    <mc:Fallback xmlns="">
+      <p:transition>
+        <p:fade/>
+      </p:transition>
+    </mc:Fallback>
+  </mc:AlternateContent>
+</p:sld>
+</file>
+
+<file path=ppt/slides/slide3.xml><?xml version="1.0" encoding="utf-8"?>
+<p:sld xmlns:a="http://schemas.openxmlformats.org/drawingml/2006/main" xmlns:r="http://schemas.openxmlformats.org/officeDocument/2006/relationships" xmlns:p="http://schemas.openxmlformats.org/presentationml/2006/main">
+  <p:cSld>
+    <p:spTree>
+      <p:nvGrpSpPr>
+        <p:cNvPr id="1" name="">
+          <a:extLst>
+            <a:ext uri="{FF2B5EF4-FFF2-40B4-BE49-F238E27FC236}">
+              <a16:creationId xmlns:a16="http://schemas.microsoft.com/office/drawing/2014/main" id="{50979731-D669-8E7A-45D0-05C6CAE9EDF9}"/>
+            </a:ext>
+          </a:extLst>
+        </p:cNvPr>
+        <p:cNvGrpSpPr/>
+        <p:nvPr/>
+      </p:nvGrpSpPr>
+      <p:grpSpPr>
+        <a:xfrm>
+          <a:off x="0" y="0"/>
+          <a:ext cx="0" cy="0"/>
+          <a:chOff x="0" y="0"/>
+          <a:chExt cx="0" cy="0"/>
+        </a:xfrm>
+      </p:grpSpPr>
+      <p:grpSp>
+        <p:nvGrpSpPr>
+          <p:cNvPr id="2" name="Group 1">
+            <a:extLst>
+              <a:ext uri="{FF2B5EF4-FFF2-40B4-BE49-F238E27FC236}">
+                <a16:creationId xmlns:a16="http://schemas.microsoft.com/office/drawing/2014/main" id="{5F78C23E-2DAE-AF26-8959-42AF41FE99D1}"/>
+              </a:ext>
+            </a:extLst>
+          </p:cNvPr>
+          <p:cNvGrpSpPr/>
+          <p:nvPr/>
+        </p:nvGrpSpPr>
+        <p:grpSpPr>
+          <a:xfrm>
+            <a:off x="203277" y="313457"/>
+            <a:ext cx="6369628" cy="6231083"/>
+            <a:chOff x="1387185" y="313458"/>
+            <a:chExt cx="6369628" cy="6231083"/>
+          </a:xfrm>
+        </p:grpSpPr>
+        <p:sp>
+          <p:nvSpPr>
+            <p:cNvPr id="6" name="Oval 5">
+              <a:extLst>
+                <a:ext uri="{FF2B5EF4-FFF2-40B4-BE49-F238E27FC236}">
+                  <a16:creationId xmlns:a16="http://schemas.microsoft.com/office/drawing/2014/main" id="{C0F3BCD5-A832-82DB-D953-CCCFE208EF4B}"/>
+                </a:ext>
+              </a:extLst>
+            </p:cNvPr>
+            <p:cNvSpPr/>
+            <p:nvPr/>
+          </p:nvSpPr>
+          <p:spPr>
+            <a:xfrm>
+              <a:off x="3855026" y="313458"/>
+              <a:ext cx="1433946" cy="1433946"/>
+            </a:xfrm>
+            <a:prstGeom prst="ellipse">
+              <a:avLst/>
+            </a:prstGeom>
+            <a:blipFill>
+              <a:blip r:embed="rId2"/>
+              <a:stretch>
+                <a:fillRect/>
+              </a:stretch>
+            </a:blipFill>
+            <a:ln w="28575">
+              <a:solidFill>
+                <a:schemeClr val="tx1"/>
+              </a:solidFill>
+            </a:ln>
+          </p:spPr>
+          <p:style>
+            <a:lnRef idx="2">
+              <a:schemeClr val="accent1">
+                <a:shade val="15000"/>
+              </a:schemeClr>
+            </a:lnRef>
+            <a:fillRef idx="1">
+              <a:schemeClr val="accent1"/>
+            </a:fillRef>
+            <a:effectRef idx="0">
+              <a:schemeClr val="accent1"/>
+            </a:effectRef>
+            <a:fontRef idx="minor">
+              <a:schemeClr val="lt1"/>
+            </a:fontRef>
+          </p:style>
+          <p:txBody>
+            <a:bodyPr rtlCol="0" anchor="ctr"/>
+            <a:lstStyle/>
+            <a:p>
+              <a:pPr algn="ctr"/>
+              <a:endParaRPr lang="en-GB" dirty="0"/>
+            </a:p>
+          </p:txBody>
+        </p:sp>
+        <p:sp>
+          <p:nvSpPr>
+            <p:cNvPr id="14" name="Oval 13">
+              <a:extLst>
+                <a:ext uri="{FF2B5EF4-FFF2-40B4-BE49-F238E27FC236}">
+                  <a16:creationId xmlns:a16="http://schemas.microsoft.com/office/drawing/2014/main" id="{545C39D3-9493-4ABE-AA49-28C1BFCD092C}"/>
+                </a:ext>
+              </a:extLst>
+            </p:cNvPr>
+            <p:cNvSpPr/>
+            <p:nvPr/>
+          </p:nvSpPr>
+          <p:spPr>
+            <a:xfrm>
+              <a:off x="5605894" y="1030431"/>
+              <a:ext cx="1433946" cy="1433946"/>
+            </a:xfrm>
+            <a:prstGeom prst="ellipse">
+              <a:avLst/>
+            </a:prstGeom>
+            <a:blipFill>
+              <a:blip r:embed="rId3"/>
+              <a:stretch>
+                <a:fillRect/>
+              </a:stretch>
+            </a:blipFill>
+            <a:ln w="28575">
+              <a:solidFill>
+                <a:schemeClr val="tx1"/>
+              </a:solidFill>
+            </a:ln>
+          </p:spPr>
+          <p:style>
+            <a:lnRef idx="2">
+              <a:schemeClr val="accent1">
+                <a:shade val="15000"/>
+              </a:schemeClr>
+            </a:lnRef>
+            <a:fillRef idx="1">
+              <a:schemeClr val="accent1"/>
+            </a:fillRef>
+            <a:effectRef idx="0">
+              <a:schemeClr val="accent1"/>
+            </a:effectRef>
+            <a:fontRef idx="minor">
+              <a:schemeClr val="lt1"/>
+            </a:fontRef>
+          </p:style>
+          <p:txBody>
+            <a:bodyPr rtlCol="0" anchor="ctr"/>
+            <a:lstStyle/>
+            <a:p>
+              <a:pPr algn="ctr"/>
+              <a:endParaRPr lang="en-GB" dirty="0"/>
+            </a:p>
+          </p:txBody>
+        </p:sp>
+        <p:sp>
+          <p:nvSpPr>
+            <p:cNvPr id="15" name="Oval 14">
+              <a:extLst>
+                <a:ext uri="{FF2B5EF4-FFF2-40B4-BE49-F238E27FC236}">
+                  <a16:creationId xmlns:a16="http://schemas.microsoft.com/office/drawing/2014/main" id="{B380BEB4-9038-92F4-4583-F77E0B3CFE8B}"/>
+                </a:ext>
+              </a:extLst>
+            </p:cNvPr>
+            <p:cNvSpPr/>
+            <p:nvPr/>
+          </p:nvSpPr>
+          <p:spPr>
+            <a:xfrm>
+              <a:off x="6322867" y="2712026"/>
+              <a:ext cx="1433946" cy="1433946"/>
+            </a:xfrm>
+            <a:prstGeom prst="ellipse">
+              <a:avLst/>
+            </a:prstGeom>
+            <a:blipFill>
+              <a:blip r:embed="rId4"/>
+              <a:stretch>
+                <a:fillRect/>
+              </a:stretch>
+            </a:blipFill>
+            <a:ln w="28575">
+              <a:solidFill>
+                <a:schemeClr val="tx1"/>
+              </a:solidFill>
+            </a:ln>
+          </p:spPr>
+          <p:style>
+            <a:lnRef idx="2">
+              <a:schemeClr val="accent1">
+                <a:shade val="15000"/>
               </a:schemeClr>
             </a:lnRef>
             <a:fillRef idx="1">
@@ -4627,10 +4300,10 @@
         </p:sp>
         <p:sp>
           <p:nvSpPr>
-            <p:cNvPr id="41" name="Oval 40">
+            <p:cNvPr id="16" name="Oval 15">
               <a:extLst>
                 <a:ext uri="{FF2B5EF4-FFF2-40B4-BE49-F238E27FC236}">
-                  <a16:creationId xmlns:a16="http://schemas.microsoft.com/office/drawing/2014/main" id="{7FBCC76F-1C6C-40CB-93D4-FFDBDB5ED66E}"/>
+                  <a16:creationId xmlns:a16="http://schemas.microsoft.com/office/drawing/2014/main" id="{51AC8043-0010-D72D-8FF8-D485ADBE445D}"/>
                 </a:ext>
               </a:extLst>
             </p:cNvPr>
@@ -4639,25 +4312,256 @@
           </p:nvSpPr>
           <p:spPr>
             <a:xfrm>
-              <a:off x="7231590" y="1043421"/>
-              <a:ext cx="151001" cy="151001"/>
+              <a:off x="5605894" y="4393621"/>
+              <a:ext cx="1433946" cy="1433946"/>
             </a:xfrm>
             <a:prstGeom prst="ellipse">
               <a:avLst/>
             </a:prstGeom>
-            <a:solidFill>
-              <a:schemeClr val="bg2">
-                <a:lumMod val="25000"/>
-              </a:schemeClr>
-            </a:solidFill>
-            <a:ln>
-              <a:noFill/>
+            <a:blipFill>
+              <a:blip r:embed="rId5"/>
+              <a:stretch>
+                <a:fillRect/>
+              </a:stretch>
+            </a:blipFill>
+            <a:ln w="28575">
+              <a:solidFill>
+                <a:schemeClr val="tx1"/>
+              </a:solidFill>
             </a:ln>
           </p:spPr>
           <p:style>
             <a:lnRef idx="2">
               <a:schemeClr val="accent1">
-                <a:shade val="50000"/>
+                <a:shade val="15000"/>
+              </a:schemeClr>
+            </a:lnRef>
+            <a:fillRef idx="1">
+              <a:schemeClr val="accent1"/>
+            </a:fillRef>
+            <a:effectRef idx="0">
+              <a:schemeClr val="accent1"/>
+            </a:effectRef>
+            <a:fontRef idx="minor">
+              <a:schemeClr val="lt1"/>
+            </a:fontRef>
+          </p:style>
+          <p:txBody>
+            <a:bodyPr rtlCol="0" anchor="ctr"/>
+            <a:lstStyle/>
+            <a:p>
+              <a:pPr algn="ctr"/>
+              <a:endParaRPr lang="en-GB"/>
+            </a:p>
+          </p:txBody>
+        </p:sp>
+        <p:sp>
+          <p:nvSpPr>
+            <p:cNvPr id="17" name="Oval 16">
+              <a:extLst>
+                <a:ext uri="{FF2B5EF4-FFF2-40B4-BE49-F238E27FC236}">
+                  <a16:creationId xmlns:a16="http://schemas.microsoft.com/office/drawing/2014/main" id="{659CE6C0-572C-5475-B313-229393021857}"/>
+                </a:ext>
+              </a:extLst>
+            </p:cNvPr>
+            <p:cNvSpPr/>
+            <p:nvPr/>
+          </p:nvSpPr>
+          <p:spPr>
+            <a:xfrm>
+              <a:off x="3855026" y="5110595"/>
+              <a:ext cx="1433946" cy="1433946"/>
+            </a:xfrm>
+            <a:prstGeom prst="ellipse">
+              <a:avLst/>
+            </a:prstGeom>
+            <a:blipFill>
+              <a:blip r:embed="rId6"/>
+              <a:stretch>
+                <a:fillRect/>
+              </a:stretch>
+            </a:blipFill>
+            <a:ln w="28575">
+              <a:solidFill>
+                <a:schemeClr val="tx1"/>
+              </a:solidFill>
+            </a:ln>
+          </p:spPr>
+          <p:style>
+            <a:lnRef idx="2">
+              <a:schemeClr val="accent1">
+                <a:shade val="15000"/>
+              </a:schemeClr>
+            </a:lnRef>
+            <a:fillRef idx="1">
+              <a:schemeClr val="accent1"/>
+            </a:fillRef>
+            <a:effectRef idx="0">
+              <a:schemeClr val="accent1"/>
+            </a:effectRef>
+            <a:fontRef idx="minor">
+              <a:schemeClr val="lt1"/>
+            </a:fontRef>
+          </p:style>
+          <p:txBody>
+            <a:bodyPr rtlCol="0" anchor="ctr"/>
+            <a:lstStyle/>
+            <a:p>
+              <a:pPr algn="ctr"/>
+              <a:endParaRPr lang="en-GB"/>
+            </a:p>
+          </p:txBody>
+        </p:sp>
+        <p:sp>
+          <p:nvSpPr>
+            <p:cNvPr id="18" name="Oval 17">
+              <a:extLst>
+                <a:ext uri="{FF2B5EF4-FFF2-40B4-BE49-F238E27FC236}">
+                  <a16:creationId xmlns:a16="http://schemas.microsoft.com/office/drawing/2014/main" id="{42D97709-B2D8-259A-E6CC-E1F61A97C88B}"/>
+                </a:ext>
+              </a:extLst>
+            </p:cNvPr>
+            <p:cNvSpPr/>
+            <p:nvPr/>
+          </p:nvSpPr>
+          <p:spPr>
+            <a:xfrm>
+              <a:off x="2104158" y="1030431"/>
+              <a:ext cx="1433946" cy="1433946"/>
+            </a:xfrm>
+            <a:prstGeom prst="ellipse">
+              <a:avLst/>
+            </a:prstGeom>
+            <a:blipFill>
+              <a:blip r:embed="rId7"/>
+              <a:stretch>
+                <a:fillRect/>
+              </a:stretch>
+            </a:blipFill>
+            <a:ln w="28575">
+              <a:solidFill>
+                <a:schemeClr val="tx1"/>
+              </a:solidFill>
+            </a:ln>
+          </p:spPr>
+          <p:style>
+            <a:lnRef idx="2">
+              <a:schemeClr val="accent1">
+                <a:shade val="15000"/>
+              </a:schemeClr>
+            </a:lnRef>
+            <a:fillRef idx="1">
+              <a:schemeClr val="accent1"/>
+            </a:fillRef>
+            <a:effectRef idx="0">
+              <a:schemeClr val="accent1"/>
+            </a:effectRef>
+            <a:fontRef idx="minor">
+              <a:schemeClr val="lt1"/>
+            </a:fontRef>
+          </p:style>
+          <p:txBody>
+            <a:bodyPr rtlCol="0" anchor="ctr"/>
+            <a:lstStyle/>
+            <a:p>
+              <a:pPr algn="ctr"/>
+              <a:endParaRPr lang="en-GB"/>
+            </a:p>
+          </p:txBody>
+        </p:sp>
+        <p:sp>
+          <p:nvSpPr>
+            <p:cNvPr id="19" name="Oval 18">
+              <a:extLst>
+                <a:ext uri="{FF2B5EF4-FFF2-40B4-BE49-F238E27FC236}">
+                  <a16:creationId xmlns:a16="http://schemas.microsoft.com/office/drawing/2014/main" id="{84559C94-DDCB-9D1E-AE79-BF839E2D5E96}"/>
+                </a:ext>
+              </a:extLst>
+            </p:cNvPr>
+            <p:cNvSpPr/>
+            <p:nvPr/>
+          </p:nvSpPr>
+          <p:spPr>
+            <a:xfrm>
+              <a:off x="1387185" y="2712026"/>
+              <a:ext cx="1433946" cy="1433946"/>
+            </a:xfrm>
+            <a:prstGeom prst="ellipse">
+              <a:avLst/>
+            </a:prstGeom>
+            <a:blipFill>
+              <a:blip r:embed="rId8"/>
+              <a:stretch>
+                <a:fillRect/>
+              </a:stretch>
+            </a:blipFill>
+            <a:ln w="28575">
+              <a:solidFill>
+                <a:schemeClr val="tx1"/>
+              </a:solidFill>
+            </a:ln>
+          </p:spPr>
+          <p:style>
+            <a:lnRef idx="2">
+              <a:schemeClr val="accent1">
+                <a:shade val="15000"/>
+              </a:schemeClr>
+            </a:lnRef>
+            <a:fillRef idx="1">
+              <a:schemeClr val="accent1"/>
+            </a:fillRef>
+            <a:effectRef idx="0">
+              <a:schemeClr val="accent1"/>
+            </a:effectRef>
+            <a:fontRef idx="minor">
+              <a:schemeClr val="lt1"/>
+            </a:fontRef>
+          </p:style>
+          <p:txBody>
+            <a:bodyPr rtlCol="0" anchor="ctr"/>
+            <a:lstStyle/>
+            <a:p>
+              <a:pPr algn="ctr"/>
+              <a:endParaRPr lang="en-GB"/>
+            </a:p>
+          </p:txBody>
+        </p:sp>
+        <p:sp>
+          <p:nvSpPr>
+            <p:cNvPr id="20" name="Oval 19">
+              <a:extLst>
+                <a:ext uri="{FF2B5EF4-FFF2-40B4-BE49-F238E27FC236}">
+                  <a16:creationId xmlns:a16="http://schemas.microsoft.com/office/drawing/2014/main" id="{3410423F-9A79-B725-BEC8-6D38BEC178B0}"/>
+                </a:ext>
+              </a:extLst>
+            </p:cNvPr>
+            <p:cNvSpPr/>
+            <p:nvPr/>
+          </p:nvSpPr>
+          <p:spPr>
+            <a:xfrm>
+              <a:off x="2104157" y="4393621"/>
+              <a:ext cx="1433946" cy="1433946"/>
+            </a:xfrm>
+            <a:prstGeom prst="ellipse">
+              <a:avLst/>
+            </a:prstGeom>
+            <a:blipFill>
+              <a:blip r:embed="rId9"/>
+              <a:stretch>
+                <a:fillRect/>
+              </a:stretch>
+            </a:blipFill>
+            <a:ln w="28575">
+              <a:solidFill>
+                <a:schemeClr val="tx1"/>
+              </a:solidFill>
+            </a:ln>
+          </p:spPr>
+          <p:style>
+            <a:lnRef idx="2">
+              <a:schemeClr val="accent1">
+                <a:shade val="15000"/>
               </a:schemeClr>
             </a:lnRef>
             <a:fillRef idx="1">
@@ -4680,23 +4584,194 @@
           </p:txBody>
         </p:sp>
       </p:grpSp>
+      <p:sp>
+        <p:nvSpPr>
+          <p:cNvPr id="3" name="Rectangle: Rounded Corners 2">
+            <a:extLst>
+              <a:ext uri="{FF2B5EF4-FFF2-40B4-BE49-F238E27FC236}">
+                <a16:creationId xmlns:a16="http://schemas.microsoft.com/office/drawing/2014/main" id="{6EFAF89D-C968-9C01-9F1B-F526605F16F3}"/>
+              </a:ext>
+            </a:extLst>
+          </p:cNvPr>
+          <p:cNvSpPr/>
+          <p:nvPr/>
+        </p:nvSpPr>
+        <p:spPr>
+          <a:xfrm>
+            <a:off x="6789804" y="313456"/>
+            <a:ext cx="2150919" cy="6231083"/>
+          </a:xfrm>
+          <a:prstGeom prst="roundRect">
+            <a:avLst/>
+          </a:prstGeom>
+          <a:solidFill>
+            <a:schemeClr val="accent1">
+              <a:lumMod val="20000"/>
+              <a:lumOff val="80000"/>
+            </a:schemeClr>
+          </a:solidFill>
+          <a:ln w="28575">
+            <a:solidFill>
+              <a:schemeClr val="tx1"/>
+            </a:solidFill>
+          </a:ln>
+        </p:spPr>
+        <p:style>
+          <a:lnRef idx="2">
+            <a:schemeClr val="accent1">
+              <a:shade val="15000"/>
+            </a:schemeClr>
+          </a:lnRef>
+          <a:fillRef idx="1">
+            <a:schemeClr val="accent1"/>
+          </a:fillRef>
+          <a:effectRef idx="0">
+            <a:schemeClr val="accent1"/>
+          </a:effectRef>
+          <a:fontRef idx="minor">
+            <a:schemeClr val="lt1"/>
+          </a:fontRef>
+        </p:style>
+        <p:txBody>
+          <a:bodyPr rtlCol="0" anchor="ctr"/>
+          <a:lstStyle/>
+          <a:p>
+            <a:pPr algn="ctr"/>
+            <a:endParaRPr lang="en-GB"/>
+          </a:p>
+        </p:txBody>
+      </p:sp>
+      <p:sp>
+        <p:nvSpPr>
+          <p:cNvPr id="4" name="Multiplication Sign 3">
+            <a:hlinkClick r:id="" action="ppaction://hlinkshowjump?jump=previousslide"/>
+            <a:extLst>
+              <a:ext uri="{FF2B5EF4-FFF2-40B4-BE49-F238E27FC236}">
+                <a16:creationId xmlns:a16="http://schemas.microsoft.com/office/drawing/2014/main" id="{90285AAD-ED9E-7DD5-EA42-BC05C9AE7DA8}"/>
+              </a:ext>
+            </a:extLst>
+          </p:cNvPr>
+          <p:cNvSpPr/>
+          <p:nvPr/>
+        </p:nvSpPr>
+        <p:spPr>
+          <a:xfrm>
+            <a:off x="8244368" y="329766"/>
+            <a:ext cx="673769" cy="673769"/>
+          </a:xfrm>
+          <a:prstGeom prst="mathMultiply">
+            <a:avLst/>
+          </a:prstGeom>
+          <a:solidFill>
+            <a:srgbClr val="FF0000"/>
+          </a:solidFill>
+          <a:ln>
+            <a:solidFill>
+              <a:srgbClr val="C00000"/>
+            </a:solidFill>
+          </a:ln>
+        </p:spPr>
+        <p:style>
+          <a:lnRef idx="2">
+            <a:schemeClr val="accent1">
+              <a:shade val="15000"/>
+            </a:schemeClr>
+          </a:lnRef>
+          <a:fillRef idx="1">
+            <a:schemeClr val="accent1"/>
+          </a:fillRef>
+          <a:effectRef idx="0">
+            <a:schemeClr val="accent1"/>
+          </a:effectRef>
+          <a:fontRef idx="minor">
+            <a:schemeClr val="lt1"/>
+          </a:fontRef>
+        </p:style>
+        <p:txBody>
+          <a:bodyPr rtlCol="0" anchor="ctr"/>
+          <a:lstStyle/>
+          <a:p>
+            <a:pPr algn="ctr"/>
+            <a:endParaRPr lang="en-GB"/>
+          </a:p>
+        </p:txBody>
+      </p:sp>
+      <p:sp>
+        <p:nvSpPr>
+          <p:cNvPr id="7" name="Arrow: Left 6">
+            <a:hlinkClick r:id="" action="ppaction://hlinkshowjump?jump=nextslide"/>
+            <a:extLst>
+              <a:ext uri="{FF2B5EF4-FFF2-40B4-BE49-F238E27FC236}">
+                <a16:creationId xmlns:a16="http://schemas.microsoft.com/office/drawing/2014/main" id="{0056556B-D878-AB79-A5B8-E89B24207655}"/>
+              </a:ext>
+            </a:extLst>
+          </p:cNvPr>
+          <p:cNvSpPr/>
+          <p:nvPr/>
+        </p:nvSpPr>
+        <p:spPr>
+          <a:xfrm>
+            <a:off x="9230591" y="476151"/>
+            <a:ext cx="519545" cy="381000"/>
+          </a:xfrm>
+          <a:prstGeom prst="leftArrow">
+            <a:avLst/>
+          </a:prstGeom>
+        </p:spPr>
+        <p:style>
+          <a:lnRef idx="2">
+            <a:schemeClr val="accent1">
+              <a:shade val="15000"/>
+            </a:schemeClr>
+          </a:lnRef>
+          <a:fillRef idx="1">
+            <a:schemeClr val="accent1"/>
+          </a:fillRef>
+          <a:effectRef idx="0">
+            <a:schemeClr val="accent1"/>
+          </a:effectRef>
+          <a:fontRef idx="minor">
+            <a:schemeClr val="lt1"/>
+          </a:fontRef>
+        </p:style>
+        <p:txBody>
+          <a:bodyPr rtlCol="0" anchor="ctr"/>
+          <a:lstStyle/>
+          <a:p>
+            <a:pPr algn="ctr"/>
+            <a:endParaRPr lang="en-GB"/>
+          </a:p>
+        </p:txBody>
+      </p:sp>
     </p:spTree>
     <p:extLst>
       <p:ext uri="{BB962C8B-B14F-4D97-AF65-F5344CB8AC3E}">
-        <p14:creationId xmlns:p14="http://schemas.microsoft.com/office/powerpoint/2010/main" val="2681159264"/>
+        <p14:creationId xmlns:p14="http://schemas.microsoft.com/office/powerpoint/2010/main" val="2253583913"/>
       </p:ext>
     </p:extLst>
   </p:cSld>
   <p:clrMapOvr>
     <a:masterClrMapping/>
   </p:clrMapOvr>
+  <mc:AlternateContent xmlns:mc="http://schemas.openxmlformats.org/markup-compatibility/2006" xmlns:p159="http://schemas.microsoft.com/office/powerpoint/2015/09/main">
+    <mc:Choice Requires="p159">
+      <p:transition>
+        <p159:morph option="byObject"/>
+      </p:transition>
+    </mc:Choice>
+    <mc:Fallback xmlns="">
+      <p:transition>
+        <p:fade/>
+      </p:transition>
+    </mc:Fallback>
+  </mc:AlternateContent>
 </p:sld>
 </file>
 
 <file path=ppt/theme/theme1.xml><?xml version="1.0" encoding="utf-8"?>
-<a:theme xmlns:a="http://schemas.openxmlformats.org/drawingml/2006/main" name="Office Theme">
+<a:theme xmlns:a="http://schemas.openxmlformats.org/drawingml/2006/main" name="Office 2013 - 2022 Theme">
   <a:themeElements>
-    <a:clrScheme name="Office">
+    <a:clrScheme name="Office 2013 - 2022 Theme">
       <a:dk1>
         <a:sysClr val="windowText" lastClr="000000"/>
       </a:dk1>
@@ -4734,7 +4809,7 @@
         <a:srgbClr val="954F72"/>
       </a:folHlink>
     </a:clrScheme>
-    <a:fontScheme name="Office">
+    <a:fontScheme name="Office 2013 - 2022 Theme">
       <a:majorFont>
         <a:latin typeface="Calibri Light" panose="020F0302020204030204"/>
         <a:ea typeface=""/>
@@ -4769,23 +4844,6 @@
         <a:font script="Viet" typeface="Times New Roman"/>
         <a:font script="Uigh" typeface="Microsoft Uighur"/>
         <a:font script="Geor" typeface="Sylfaen"/>
-        <a:font script="Armn" typeface="Arial"/>
-        <a:font script="Bugi" typeface="Leelawadee UI"/>
-        <a:font script="Bopo" typeface="Microsoft JhengHei"/>
-        <a:font script="Java" typeface="Javanese Text"/>
-        <a:font script="Lisu" typeface="Segoe UI"/>
-        <a:font script="Mymr" typeface="Myanmar Text"/>
-        <a:font script="Nkoo" typeface="Ebrima"/>
-        <a:font script="Olck" typeface="Nirmala UI"/>
-        <a:font script="Osma" typeface="Ebrima"/>
-        <a:font script="Phag" typeface="Phagspa"/>
-        <a:font script="Syrn" typeface="Estrangelo Edessa"/>
-        <a:font script="Syrj" typeface="Estrangelo Edessa"/>
-        <a:font script="Syre" typeface="Estrangelo Edessa"/>
-        <a:font script="Sora" typeface="Nirmala UI"/>
-        <a:font script="Tale" typeface="Microsoft Tai Le"/>
-        <a:font script="Talu" typeface="Microsoft New Tai Lue"/>
-        <a:font script="Tfng" typeface="Ebrima"/>
       </a:majorFont>
       <a:minorFont>
         <a:latin typeface="Calibri" panose="020F0502020204030204"/>
@@ -4821,26 +4879,9 @@
         <a:font script="Viet" typeface="Arial"/>
         <a:font script="Uigh" typeface="Microsoft Uighur"/>
         <a:font script="Geor" typeface="Sylfaen"/>
-        <a:font script="Armn" typeface="Arial"/>
-        <a:font script="Bugi" typeface="Leelawadee UI"/>
-        <a:font script="Bopo" typeface="Microsoft JhengHei"/>
-        <a:font script="Java" typeface="Javanese Text"/>
-        <a:font script="Lisu" typeface="Segoe UI"/>
-        <a:font script="Mymr" typeface="Myanmar Text"/>
-        <a:font script="Nkoo" typeface="Ebrima"/>
-        <a:font script="Olck" typeface="Nirmala UI"/>
-        <a:font script="Osma" typeface="Ebrima"/>
-        <a:font script="Phag" typeface="Phagspa"/>
-        <a:font script="Syrn" typeface="Estrangelo Edessa"/>
-        <a:font script="Syrj" typeface="Estrangelo Edessa"/>
-        <a:font script="Syre" typeface="Estrangelo Edessa"/>
-        <a:font script="Sora" typeface="Nirmala UI"/>
-        <a:font script="Tale" typeface="Microsoft Tai Le"/>
-        <a:font script="Talu" typeface="Microsoft New Tai Lue"/>
-        <a:font script="Tfng" typeface="Ebrima"/>
       </a:minorFont>
     </a:fontScheme>
-    <a:fmtScheme name="Office">
+    <a:fmtScheme name="Office 2013 - 2022 Theme">
       <a:fillStyleLst>
         <a:solidFill>
           <a:schemeClr val="phClr"/>
@@ -4982,7 +5023,7 @@
   <a:extraClrSchemeLst/>
   <a:extLst>
     <a:ext uri="{05A4C25C-085E-4340-85A3-A5531E510DB2}">
-      <thm15:themeFamily xmlns:thm15="http://schemas.microsoft.com/office/thememl/2012/main" name="Office Theme" id="{62F939B6-93AF-4DB8-9C6B-D6C7DFDC589F}" vid="{4A3C46E8-61CC-4603-A589-7422A47A8E4A}"/>
+      <thm15:themeFamily xmlns:thm15="http://schemas.microsoft.com/office/thememl/2012/main" name="Office 2013 - 2022 Theme" id="{62F939B6-93AF-4DB8-9C6B-D6C7DFDC589F}" vid="{4A3C46E8-61CC-4603-A589-7422A47A8E4A}"/>
     </a:ext>
   </a:extLst>
 </a:theme>

</xml_diff>